<commit_message>
Support paywalled papers: save abstract now, attach PDF later
- add <PDF> matches an existing entry by DOI/arXiv, then by title,
  and keeps the existing bibliographic data, filling only gaps
- add <PDF> --key <citekey> attaches a PDF whose title can't be read
- list shows PDF-waiting entries; list --pending filters them
- clearer note when no open-access PDF is available
- docs (SKILL, README, usage guide in 4 formats) describe the flow

Co-Authored-By: Claude Opus 5.5 <noreply@anthropic.com>
</commit_message>
<xml_diff>
--- a/docs/paper-summary_사용가이드.pptx
+++ b/docs/paper-summary_사용가이드.pptx
@@ -8571,7 +8571,7 @@
                 <a:latin typeface="맑은 고딕"/>
                 <a:ea typeface="맑은 고딕"/>
               </a:rPr>
-              <a:t>유료 논문은 서지 정보만 등록</a:t>
+              <a:t>유료 논문은 서지·초록만 저장 (PDF대기)</a:t>
             </a:r>
           </a:p>
           <a:p>
@@ -8588,7 +8588,7 @@
                 <a:latin typeface="맑은 고딕"/>
                 <a:ea typeface="맑은 고딕"/>
               </a:rPr>
-              <a:t>받은 PDF 경로로 다시 추가하면 본문·그림 추출</a:t>
+              <a:t>받은 PDF를 넣으면 같은 항목에 본문·그림 채움</a:t>
             </a:r>
           </a:p>
         </p:txBody>

</xml_diff>

<commit_message>
Rewrite usage guide around natural-language prompts to Claude
- guide (md/docx/pdf/pptx) and README show what to say to Claude
  for each task; CLI commands move to an appendix
- SKILL.md handles install/update requests, finding a source for a
  sentence, summarizing unsummarized papers, and missing cite keys

Co-Authored-By: Claude Opus 5.5 <noreply@anthropic.com>
</commit_message>
<xml_diff>
--- a/docs/paper-summary_사용가이드.pptx
+++ b/docs/paper-summary_사용가이드.pptx
@@ -650,7 +650,7 @@
           <a:lstStyle/>
           <a:p>
             <a:r>
-              <a:t>주제 검색만 SciSpace 커넥터가 필요하고, 나머지 기능은 커넥터 없이 동작합니다.</a:t>
+              <a:t>Claude에게 설치를 맡기면 clone과 패키지 설치를 대신 합니다. 주제 검색만 SciSpace 커넥터가 필요합니다.</a:t>
             </a:r>
           </a:p>
         </p:txBody>
@@ -930,7 +930,7 @@
           <a:lstStyle/>
           <a:p>
             <a:r>
-              <a:t>평소에는 말로 시키면 Claude가 이 명령들을 대신 실행합니다.</a:t>
+              <a:t>처음에 /paper-summary를 붙이면 이 스킬을 확실히 씁니다. 붙이지 않아도 논문·참고문헌 관련 말이면 Claude가 알아서 고릅니다.</a:t>
             </a:r>
           </a:p>
         </p:txBody>
@@ -5498,7 +5498,7 @@
                 <a:latin typeface="맑은 고딕"/>
                 <a:ea typeface="맑은 고딕"/>
               </a:rPr>
-              <a:t>설치는 명령 두 줄</a:t>
+              <a:t>설치도 말 한마디로</a:t>
             </a:r>
           </a:p>
         </p:txBody>
@@ -5552,7 +5552,167 @@
         <p:spPr>
           <a:xfrm>
             <a:off x="548640" y="1783080"/>
-            <a:ext cx="6949440" cy="1773936"/>
+            <a:ext cx="6949440" cy="2331720"/>
+          </a:xfrm>
+          <a:prstGeom prst="roundRect">
+            <a:avLst>
+              <a:gd name="adj" fmla="val 6000"/>
+            </a:avLst>
+          </a:prstGeom>
+          <a:solidFill>
+            <a:srgbClr val="F1F7F6"/>
+          </a:solidFill>
+          <a:ln>
+            <a:noFill/>
+          </a:ln>
+          <a:effectLst/>
+        </p:spPr>
+        <p:style>
+          <a:lnRef idx="1">
+            <a:schemeClr val="accent1"/>
+          </a:lnRef>
+          <a:fillRef idx="3">
+            <a:schemeClr val="accent1"/>
+          </a:fillRef>
+          <a:effectRef idx="2">
+            <a:schemeClr val="accent1"/>
+          </a:effectRef>
+          <a:fontRef idx="minor">
+            <a:schemeClr val="lt1"/>
+          </a:fontRef>
+        </p:style>
+        <p:txBody>
+          <a:bodyPr rtlCol="0" anchor="ctr"/>
+          <a:lstStyle/>
+          <a:p>
+            <a:pPr algn="ctr"/>
+          </a:p>
+        </p:txBody>
+      </p:sp>
+      <p:sp>
+        <p:nvSpPr>
+          <p:cNvPr id="5" name="TextBox 4"/>
+          <p:cNvSpPr txBox="1"/>
+          <p:nvPr/>
+        </p:nvSpPr>
+        <p:spPr>
+          <a:xfrm>
+            <a:off x="822960" y="1965960"/>
+            <a:ext cx="6400800" cy="320040"/>
+          </a:xfrm>
+          <a:prstGeom prst="rect">
+            <a:avLst/>
+          </a:prstGeom>
+          <a:noFill/>
+        </p:spPr>
+        <p:txBody>
+          <a:bodyPr wrap="square" lIns="0" rIns="0" tIns="0" bIns="0" anchor="t">
+            <a:spAutoFit/>
+          </a:bodyPr>
+          <a:lstStyle/>
+          <a:p>
+            <a:pPr algn="l">
+              <a:spcAft>
+                <a:spcPts val="600"/>
+              </a:spcAft>
+            </a:pPr>
+            <a:r>
+              <a:rPr sz="1300" b="1">
+                <a:solidFill>
+                  <a:srgbClr val="0B5C5A"/>
+                </a:solidFill>
+                <a:latin typeface="맑은 고딕"/>
+                <a:ea typeface="맑은 고딕"/>
+              </a:rPr>
+              <a:t>Claude에게 이렇게 말하기</a:t>
+            </a:r>
+          </a:p>
+        </p:txBody>
+      </p:sp>
+      <p:sp>
+        <p:nvSpPr>
+          <p:cNvPr id="6" name="TextBox 5"/>
+          <p:cNvSpPr txBox="1"/>
+          <p:nvPr/>
+        </p:nvSpPr>
+        <p:spPr>
+          <a:xfrm>
+            <a:off x="822960" y="2377440"/>
+            <a:ext cx="6400800" cy="1645920"/>
+          </a:xfrm>
+          <a:prstGeom prst="rect">
+            <a:avLst/>
+          </a:prstGeom>
+          <a:noFill/>
+        </p:spPr>
+        <p:txBody>
+          <a:bodyPr wrap="square" lIns="0" rIns="0" tIns="0" bIns="0" anchor="t">
+            <a:spAutoFit/>
+          </a:bodyPr>
+          <a:lstStyle/>
+          <a:p>
+            <a:pPr algn="l">
+              <a:spcAft>
+                <a:spcPts val="200"/>
+              </a:spcAft>
+            </a:pPr>
+            <a:r>
+              <a:rPr sz="1900" b="0">
+                <a:solidFill>
+                  <a:srgbClr val="1F292B"/>
+                </a:solidFill>
+                <a:latin typeface="맑은 고딕"/>
+                <a:ea typeface="맑은 고딕"/>
+              </a:rPr>
+              <a:t>“https://github.com/emilyJ7/paper-summary 스킬을</a:t>
+            </a:r>
+          </a:p>
+          <a:p>
+            <a:pPr algn="l">
+              <a:spcAft>
+                <a:spcPts val="200"/>
+              </a:spcAft>
+            </a:pPr>
+            <a:r>
+              <a:rPr sz="1900" b="0">
+                <a:solidFill>
+                  <a:srgbClr val="1F292B"/>
+                </a:solidFill>
+                <a:latin typeface="맑은 고딕"/>
+                <a:ea typeface="맑은 고딕"/>
+              </a:rPr>
+              <a:t>~/.claude/skills/paper-summary에 설치하고</a:t>
+            </a:r>
+          </a:p>
+          <a:p>
+            <a:pPr algn="l">
+              <a:spcAft>
+                <a:spcPts val="200"/>
+              </a:spcAft>
+            </a:pPr>
+            <a:r>
+              <a:rPr sz="1900" b="0">
+                <a:solidFill>
+                  <a:srgbClr val="1F292B"/>
+                </a:solidFill>
+                <a:latin typeface="맑은 고딕"/>
+                <a:ea typeface="맑은 고딕"/>
+              </a:rPr>
+              <a:t>필요한 파이썬 패키지도 설치해줘”</a:t>
+            </a:r>
+          </a:p>
+        </p:txBody>
+      </p:sp>
+      <p:sp>
+        <p:nvSpPr>
+          <p:cNvPr id="7" name="Rounded Rectangle 6"/>
+          <p:cNvSpPr/>
+          <p:nvPr/>
+        </p:nvSpPr>
+        <p:spPr>
+          <a:xfrm>
+            <a:off x="548640" y="4389120"/>
+            <a:ext cx="6949440" cy="1188720"/>
           </a:xfrm>
           <a:prstGeom prst="roundRect">
             <a:avLst>
@@ -5591,13 +5751,13 @@
       </p:sp>
       <p:sp>
         <p:nvSpPr>
-          <p:cNvPr id="5" name="TextBox 4"/>
+          <p:cNvPr id="8" name="TextBox 7"/>
           <p:cNvSpPr txBox="1"/>
           <p:nvPr/>
         </p:nvSpPr>
         <p:spPr>
           <a:xfrm>
-            <a:off x="777240" y="1947672"/>
+            <a:off x="777240" y="4553712"/>
             <a:ext cx="6492240" cy="274320"/>
           </a:xfrm>
           <a:prstGeom prst="rect">
@@ -5624,21 +5784,21 @@
                 <a:latin typeface="맑은 고딕"/>
                 <a:ea typeface="맑은 고딕"/>
               </a:rPr>
-              <a:t>Windows (PowerShell)</a:t>
-            </a:r>
-          </a:p>
-        </p:txBody>
-      </p:sp>
-      <p:sp>
-        <p:nvSpPr>
-          <p:cNvPr id="6" name="TextBox 5"/>
+              <a:t>직접 설치할 때 (Git Bash · macOS · Linux)</a:t>
+            </a:r>
+          </a:p>
+        </p:txBody>
+      </p:sp>
+      <p:sp>
+        <p:nvSpPr>
+          <p:cNvPr id="9" name="TextBox 8"/>
           <p:cNvSpPr txBox="1"/>
           <p:nvPr/>
         </p:nvSpPr>
         <p:spPr>
           <a:xfrm>
-            <a:off x="777240" y="2240279"/>
-            <a:ext cx="6492240" cy="1499616"/>
+            <a:off x="777240" y="4846320"/>
+            <a:ext cx="6492240" cy="914400"/>
           </a:xfrm>
           <a:prstGeom prst="rect">
             <a:avLst/>
@@ -5657,14 +5817,14 @@
               </a:spcAft>
             </a:pPr>
             <a:r>
-              <a:rPr sz="1200" b="0">
+              <a:rPr sz="1100" b="0">
                 <a:solidFill>
                   <a:srgbClr val="E6EDEE"/>
                 </a:solidFill>
                 <a:latin typeface="Consolas"/>
                 <a:ea typeface="맑은 고딕"/>
               </a:rPr>
-              <a:t>git clone https://github.com/emilyJ7/paper-summary.git `</a:t>
+              <a:t>git clone https://github.com/emilyJ7/paper-summary.git ~/.claude/skills/paper-summary</a:t>
             </a:r>
           </a:p>
           <a:p>
@@ -5674,225 +5834,14 @@
               </a:spcAft>
             </a:pPr>
             <a:r>
-              <a:rPr sz="1200" b="0">
+              <a:rPr sz="1100" b="0">
                 <a:solidFill>
                   <a:srgbClr val="E6EDEE"/>
                 </a:solidFill>
                 <a:latin typeface="Consolas"/>
                 <a:ea typeface="맑은 고딕"/>
               </a:rPr>
-              <a:t>  "$HOME\.claude\skills\paper-summary"</a:t>
-            </a:r>
-          </a:p>
-          <a:p>
-            <a:pPr algn="l">
-              <a:spcAft>
-                <a:spcPts val="200"/>
-              </a:spcAft>
-            </a:pPr>
-            <a:r>
-              <a:rPr sz="1200" b="0">
-                <a:solidFill>
-                  <a:srgbClr val="E6EDEE"/>
-                </a:solidFill>
-                <a:latin typeface="Consolas"/>
-                <a:ea typeface="맑은 고딕"/>
-              </a:rPr>
-              <a:t>python -m pip install -r `</a:t>
-            </a:r>
-          </a:p>
-          <a:p>
-            <a:pPr algn="l">
-              <a:spcAft>
-                <a:spcPts val="200"/>
-              </a:spcAft>
-            </a:pPr>
-            <a:r>
-              <a:rPr sz="1200" b="0">
-                <a:solidFill>
-                  <a:srgbClr val="E6EDEE"/>
-                </a:solidFill>
-                <a:latin typeface="Consolas"/>
-                <a:ea typeface="맑은 고딕"/>
-              </a:rPr>
-              <a:t>  "$HOME\.claude\skills\paper-summary\requirements.txt"</a:t>
-            </a:r>
-          </a:p>
-        </p:txBody>
-      </p:sp>
-      <p:sp>
-        <p:nvSpPr>
-          <p:cNvPr id="7" name="Rounded Rectangle 6"/>
-          <p:cNvSpPr/>
-          <p:nvPr/>
-        </p:nvSpPr>
-        <p:spPr>
-          <a:xfrm>
-            <a:off x="548640" y="3831336"/>
-            <a:ext cx="6949440" cy="1773936"/>
-          </a:xfrm>
-          <a:prstGeom prst="roundRect">
-            <a:avLst>
-              <a:gd name="adj" fmla="val 4000"/>
-            </a:avLst>
-          </a:prstGeom>
-          <a:solidFill>
-            <a:srgbClr val="1B2628"/>
-          </a:solidFill>
-          <a:ln>
-            <a:noFill/>
-          </a:ln>
-          <a:effectLst/>
-        </p:spPr>
-        <p:style>
-          <a:lnRef idx="1">
-            <a:schemeClr val="accent1"/>
-          </a:lnRef>
-          <a:fillRef idx="3">
-            <a:schemeClr val="accent1"/>
-          </a:fillRef>
-          <a:effectRef idx="2">
-            <a:schemeClr val="accent1"/>
-          </a:effectRef>
-          <a:fontRef idx="minor">
-            <a:schemeClr val="lt1"/>
-          </a:fontRef>
-        </p:style>
-        <p:txBody>
-          <a:bodyPr rtlCol="0" anchor="ctr"/>
-          <a:lstStyle/>
-          <a:p>
-            <a:pPr algn="ctr"/>
-          </a:p>
-        </p:txBody>
-      </p:sp>
-      <p:sp>
-        <p:nvSpPr>
-          <p:cNvPr id="8" name="TextBox 7"/>
-          <p:cNvSpPr txBox="1"/>
-          <p:nvPr/>
-        </p:nvSpPr>
-        <p:spPr>
-          <a:xfrm>
-            <a:off x="777240" y="3995928"/>
-            <a:ext cx="6492240" cy="274320"/>
-          </a:xfrm>
-          <a:prstGeom prst="rect">
-            <a:avLst/>
-          </a:prstGeom>
-          <a:noFill/>
-        </p:spPr>
-        <p:txBody>
-          <a:bodyPr wrap="square" lIns="0" rIns="0" tIns="0" bIns="0" anchor="t">
-            <a:spAutoFit/>
-          </a:bodyPr>
-          <a:lstStyle/>
-          <a:p>
-            <a:pPr algn="l">
-              <a:spcAft>
-                <a:spcPts val="600"/>
-              </a:spcAft>
-            </a:pPr>
-            <a:r>
-              <a:rPr sz="1100" b="1">
-                <a:solidFill>
-                  <a:srgbClr val="8FD3C8"/>
-                </a:solidFill>
-                <a:latin typeface="맑은 고딕"/>
-                <a:ea typeface="맑은 고딕"/>
-              </a:rPr>
-              <a:t>macOS / Linux</a:t>
-            </a:r>
-          </a:p>
-        </p:txBody>
-      </p:sp>
-      <p:sp>
-        <p:nvSpPr>
-          <p:cNvPr id="9" name="TextBox 8"/>
-          <p:cNvSpPr txBox="1"/>
-          <p:nvPr/>
-        </p:nvSpPr>
-        <p:spPr>
-          <a:xfrm>
-            <a:off x="777240" y="4288536"/>
-            <a:ext cx="6492240" cy="1499616"/>
-          </a:xfrm>
-          <a:prstGeom prst="rect">
-            <a:avLst/>
-          </a:prstGeom>
-          <a:noFill/>
-        </p:spPr>
-        <p:txBody>
-          <a:bodyPr wrap="square" lIns="0" rIns="0" tIns="0" bIns="0" anchor="t">
-            <a:spAutoFit/>
-          </a:bodyPr>
-          <a:lstStyle/>
-          <a:p>
-            <a:pPr algn="l">
-              <a:spcAft>
-                <a:spcPts val="200"/>
-              </a:spcAft>
-            </a:pPr>
-            <a:r>
-              <a:rPr sz="1200" b="0">
-                <a:solidFill>
-                  <a:srgbClr val="E6EDEE"/>
-                </a:solidFill>
-                <a:latin typeface="Consolas"/>
-                <a:ea typeface="맑은 고딕"/>
-              </a:rPr>
-              <a:t>git clone https://github.com/emilyJ7/paper-summary.git \</a:t>
-            </a:r>
-          </a:p>
-          <a:p>
-            <a:pPr algn="l">
-              <a:spcAft>
-                <a:spcPts val="200"/>
-              </a:spcAft>
-            </a:pPr>
-            <a:r>
-              <a:rPr sz="1200" b="0">
-                <a:solidFill>
-                  <a:srgbClr val="E6EDEE"/>
-                </a:solidFill>
-                <a:latin typeface="Consolas"/>
-                <a:ea typeface="맑은 고딕"/>
-              </a:rPr>
-              <a:t>  ~/.claude/skills/paper-summary</a:t>
-            </a:r>
-          </a:p>
-          <a:p>
-            <a:pPr algn="l">
-              <a:spcAft>
-                <a:spcPts val="200"/>
-              </a:spcAft>
-            </a:pPr>
-            <a:r>
-              <a:rPr sz="1200" b="0">
-                <a:solidFill>
-                  <a:srgbClr val="E6EDEE"/>
-                </a:solidFill>
-                <a:latin typeface="Consolas"/>
-                <a:ea typeface="맑은 고딕"/>
-              </a:rPr>
-              <a:t>python3 -m pip install -r \</a:t>
-            </a:r>
-          </a:p>
-          <a:p>
-            <a:pPr algn="l">
-              <a:spcAft>
-                <a:spcPts val="200"/>
-              </a:spcAft>
-            </a:pPr>
-            <a:r>
-              <a:rPr sz="1200" b="0">
-                <a:solidFill>
-                  <a:srgbClr val="E6EDEE"/>
-                </a:solidFill>
-                <a:latin typeface="Consolas"/>
-                <a:ea typeface="맑은 고딕"/>
-              </a:rPr>
-              <a:t>  ~/.claude/skills/paper-summary/requirements.txt</a:t>
+              <a:t>python -m pip install -r ~/.claude/skills/paper-summary/requirements.txt</a:t>
             </a:r>
           </a:p>
         </p:txBody>
@@ -6064,14 +6013,14 @@
               </a:spcAft>
             </a:pPr>
             <a:r>
-              <a:rPr sz="1200" b="0">
-                <a:solidFill>
-                  <a:srgbClr val="0B5C5A"/>
-                </a:solidFill>
-                <a:latin typeface="Consolas"/>
+              <a:rPr sz="1400" b="0">
+                <a:solidFill>
+                  <a:srgbClr val="1F292B"/>
+                </a:solidFill>
+                <a:latin typeface="맑은 고딕"/>
                 <a:ea typeface="맑은 고딕"/>
               </a:rPr>
-              <a:t>paperlib.py add 2510.27028</a:t>
+              <a:t>Claude Code 재시작 후</a:t>
             </a:r>
           </a:p>
           <a:p>
@@ -6088,7 +6037,7 @@
                 <a:latin typeface="맑은 고딕"/>
                 <a:ea typeface="맑은 고딕"/>
               </a:rPr>
-              <a:t>~/paper-library에 폴더가 생기면 성공</a:t>
+              <a:t>“arXiv 2510.27028 논문</a:t>
             </a:r>
           </a:p>
           <a:p>
@@ -6105,7 +6054,7 @@
                 <a:latin typeface="맑은 고딕"/>
                 <a:ea typeface="맑은 고딕"/>
               </a:rPr>
-              <a:t>Claude Code를 다시 시작하면 스킬 표시</a:t>
+              <a:t>라이브러리에 추가해봐”</a:t>
             </a:r>
           </a:p>
         </p:txBody>
@@ -6407,7 +6356,7 @@
                 <a:latin typeface="맑은 고딕"/>
                 <a:ea typeface="맑은 고딕"/>
               </a:rPr>
-              <a:t>/paper-summary &lt;주제&gt; — 기간·대상·편수 같은 조건이 있으면 함께 말하기</a:t>
+              <a:t>“/paper-summary 최근 3년 LLM 에이전트 메모리 연구 10편 비교해줘”</a:t>
             </a:r>
           </a:p>
         </p:txBody>
@@ -7567,7 +7516,7 @@
                 <a:latin typeface="맑은 고딕"/>
                 <a:ea typeface="맑은 고딕"/>
               </a:rPr>
-              <a:t>결과물 </a:t>
+              <a:t>이어서 말하기  </a:t>
             </a:r>
             <a:r>
               <a:rPr sz="1500" b="0">
@@ -7577,7 +7526,7 @@
                 <a:latin typeface="맑은 고딕"/>
                 <a:ea typeface="맑은 고딕"/>
               </a:rPr>
-              <a:t>Markdown 문헌 조사 보고서. 요청하면 Word·PDF·한글(hwpx)로도 만듭니다.</a:t>
+              <a:t>“여기서 고른 논문들 라이브러리에도 등록해줘”</a:t>
             </a:r>
           </a:p>
           <a:p>
@@ -7587,14 +7536,14 @@
               </a:spcAft>
             </a:pPr>
             <a:r>
-              <a:rPr sz="1500" b="1">
-                <a:solidFill>
-                  <a:srgbClr val="0B5C5A"/>
+              <a:rPr sz="1500" b="0">
+                <a:solidFill>
+                  <a:srgbClr val="1F292B"/>
                 </a:solidFill>
                 <a:latin typeface="맑은 고딕"/>
                 <a:ea typeface="맑은 고딕"/>
               </a:rPr>
-              <a:t>다음 단계 </a:t>
+              <a:t/>
             </a:r>
             <a:r>
               <a:rPr sz="1500" b="0">
@@ -7604,7 +7553,7 @@
                 <a:latin typeface="맑은 고딕"/>
                 <a:ea typeface="맑은 고딕"/>
               </a:rPr>
-              <a:t>"라이브러리에도 등록해줘" → 고른 논문을 ② 방식으로 저장</a:t>
+              <a:t>                       “이 결과 한글(hwpx) 문서로 만들어줘”  ·  “2번하고 5번 논문만 자세히 비교해줘”</a:t>
             </a:r>
           </a:p>
         </p:txBody>
@@ -7710,7 +7659,7 @@
                 <a:latin typeface="맑은 고딕"/>
                 <a:ea typeface="맑은 고딕"/>
               </a:rPr>
-              <a:t>입력: DOI · arXiv 번호/URL · PDF 파일 경로 · PDF URL</a:t>
+              <a:t>“이 논문 라이브러리에 추가하고 요약해줘: &lt;DOI · arXiv 번호 · PDF 경로&gt;”</a:t>
             </a:r>
           </a:p>
         </p:txBody>
@@ -8588,7 +8537,7 @@
                 <a:latin typeface="맑은 고딕"/>
                 <a:ea typeface="맑은 고딕"/>
               </a:rPr>
-              <a:t>받은 PDF를 넣으면 같은 항목에 본문·그림 채움</a:t>
+              <a:t>PDF를 받으면 “이 PDF로 정리해줘: &lt;경로&gt;”</a:t>
             </a:r>
           </a:p>
         </p:txBody>
@@ -8694,7 +8643,7 @@
                 <a:latin typeface="맑은 고딕"/>
                 <a:ea typeface="맑은 고딕"/>
               </a:rPr>
-              <a:t>원고에는 인용 키만 — 번호와 저자명은 cite가 채운다</a:t>
+              <a:t>“라이브러리 HRV 논문들로 연구 배경 써주고 참고문헌 APA로 달아줘”</a:t>
             </a:r>
           </a:p>
         </p:txBody>
@@ -8780,7 +8729,7 @@
                 <a:latin typeface="맑은 고딕"/>
                 <a:ea typeface="맑은 고딕"/>
               </a:rPr>
-              <a:t>원고 (원본은 그대로 보존)</a:t>
+              <a:t>내 원고 (인용 자리에 키만)</a:t>
             </a:r>
           </a:p>
         </p:txBody>
@@ -8910,8 +8859,8 @@
         </p:nvSpPr>
         <p:spPr>
           <a:xfrm>
-            <a:off x="5669280" y="3017520"/>
-            <a:ext cx="822960" cy="274320"/>
+            <a:off x="5532120" y="3017520"/>
+            <a:ext cx="1097280" cy="274320"/>
           </a:xfrm>
           <a:prstGeom prst="rect">
             <a:avLst/>
@@ -8934,10 +8883,10 @@
                 <a:solidFill>
                   <a:srgbClr val="E89B2E"/>
                 </a:solidFill>
-                <a:latin typeface="Consolas"/>
+                <a:latin typeface="맑은 고딕"/>
                 <a:ea typeface="맑은 고딕"/>
               </a:rPr>
-              <a:t>cite</a:t>
+              <a:t>“달아줘”</a:t>
             </a:r>
           </a:p>
         </p:txBody>
@@ -9468,7 +9417,7 @@
                 <a:latin typeface="맑은 고딕"/>
                 <a:ea typeface="맑은 고딕"/>
               </a:rPr>
-              <a:t>없는 키는 ??키로 표시 · --table 옵션은 한글 문서용 참고문헌 표 · library.bib는 LaTeX에서 그대로 사용</a:t>
+              <a:t>“draft.md 참고문헌 IEEE로 달아줘” · “한글 문서용 표로” · 키를 모르면 “SDNN 다룬 논문 인용 키 알려줘”</a:t>
             </a:r>
           </a:p>
         </p:txBody>
@@ -9534,7 +9483,7 @@
                 <a:latin typeface="맑은 고딕"/>
                 <a:ea typeface="맑은 고딕"/>
               </a:rPr>
-              <a:t>직접 실행할 때의 명령어</a:t>
+              <a:t>이럴 땐 이렇게 말하세요</a:t>
             </a:r>
           </a:p>
         </p:txBody>
@@ -9574,7 +9523,7 @@
                 <a:latin typeface="맑은 고딕"/>
                 <a:ea typeface="맑은 고딕"/>
               </a:rPr>
-              <a:t>python ~/.claude/skills/paper-summary/scripts/paperlib.py &lt;명령&gt;  (macOS·Linux는 python3)</a:t>
+              <a:t>명령어를 외울 필요 없이 — Claude가 알아서 실행합니다</a:t>
             </a:r>
           </a:p>
         </p:txBody>
@@ -9587,8 +9536,8 @@
         </p:nvSpPr>
         <p:spPr>
           <a:xfrm>
-            <a:off x="548640" y="1828800"/>
-            <a:ext cx="5440680" cy="914400"/>
+            <a:off x="548640" y="1783080"/>
+            <a:ext cx="5440680" cy="987552"/>
           </a:xfrm>
           <a:prstGeom prst="roundRect">
             <a:avLst>
@@ -9633,8 +9582,8 @@
         </p:nvSpPr>
         <p:spPr>
           <a:xfrm>
-            <a:off x="822959" y="1956816"/>
-            <a:ext cx="4937760" cy="365760"/>
+            <a:off x="822959" y="1911095"/>
+            <a:ext cx="4937760" cy="320040"/>
           </a:xfrm>
           <a:prstGeom prst="rect">
             <a:avLst/>
@@ -9653,14 +9602,14 @@
               </a:spcAft>
             </a:pPr>
             <a:r>
-              <a:rPr sz="1400" b="1">
+              <a:rPr sz="1300" b="1">
                 <a:solidFill>
                   <a:srgbClr val="0B5C5A"/>
                 </a:solidFill>
-                <a:latin typeface="Consolas"/>
+                <a:latin typeface="맑은 고딕"/>
                 <a:ea typeface="맑은 고딕"/>
               </a:rPr>
-              <a:t>add &lt;입력&gt; [--no-pdf]</a:t>
+              <a:t>가진 PDF 정리</a:t>
             </a:r>
           </a:p>
         </p:txBody>
@@ -9673,8 +9622,8 @@
         </p:nvSpPr>
         <p:spPr>
           <a:xfrm>
-            <a:off x="822959" y="2331720"/>
-            <a:ext cx="4937760" cy="365760"/>
+            <a:off x="822959" y="2258568"/>
+            <a:ext cx="4937760" cy="411480"/>
           </a:xfrm>
           <a:prstGeom prst="rect">
             <a:avLst/>
@@ -9693,14 +9642,14 @@
               </a:spcAft>
             </a:pPr>
             <a:r>
-              <a:rPr sz="1400" b="0">
+              <a:rPr sz="1600" b="0">
                 <a:solidFill>
                   <a:srgbClr val="1F292B"/>
                 </a:solidFill>
                 <a:latin typeface="맑은 고딕"/>
                 <a:ea typeface="맑은 고딕"/>
               </a:rPr>
-              <a:t>논문 등록, 본문·그림 추출</a:t>
+              <a:t>“Downloads 폴더의 paper.pdf 논문 요약해줘”</a:t>
             </a:r>
           </a:p>
         </p:txBody>
@@ -9713,8 +9662,8 @@
         </p:nvSpPr>
         <p:spPr>
           <a:xfrm>
-            <a:off x="6172200" y="1828800"/>
-            <a:ext cx="5440680" cy="914400"/>
+            <a:off x="6172200" y="1783080"/>
+            <a:ext cx="5440680" cy="987552"/>
           </a:xfrm>
           <a:prstGeom prst="roundRect">
             <a:avLst>
@@ -9759,8 +9708,8 @@
         </p:nvSpPr>
         <p:spPr>
           <a:xfrm>
-            <a:off x="6446520" y="1956816"/>
-            <a:ext cx="4937760" cy="365760"/>
+            <a:off x="6446520" y="1911095"/>
+            <a:ext cx="4937760" cy="320040"/>
           </a:xfrm>
           <a:prstGeom prst="rect">
             <a:avLst/>
@@ -9779,14 +9728,14 @@
               </a:spcAft>
             </a:pPr>
             <a:r>
-              <a:rPr sz="1400" b="1">
+              <a:rPr sz="1300" b="1">
                 <a:solidFill>
                   <a:srgbClr val="0B5C5A"/>
                 </a:solidFill>
-                <a:latin typeface="Consolas"/>
+                <a:latin typeface="맑은 고딕"/>
                 <a:ea typeface="맑은 고딕"/>
               </a:rPr>
-              <a:t>list</a:t>
+              <a:t>저장한 논문 찾기</a:t>
             </a:r>
           </a:p>
         </p:txBody>
@@ -9799,8 +9748,8 @@
         </p:nvSpPr>
         <p:spPr>
           <a:xfrm>
-            <a:off x="6446520" y="2331720"/>
-            <a:ext cx="4937760" cy="365760"/>
+            <a:off x="6446520" y="2258568"/>
+            <a:ext cx="4937760" cy="411480"/>
           </a:xfrm>
           <a:prstGeom prst="rect">
             <a:avLst/>
@@ -9819,14 +9768,14 @@
               </a:spcAft>
             </a:pPr>
             <a:r>
-              <a:rPr sz="1400" b="0">
+              <a:rPr sz="1600" b="0">
                 <a:solidFill>
                   <a:srgbClr val="1F292B"/>
                 </a:solidFill>
                 <a:latin typeface="맑은 고딕"/>
                 <a:ea typeface="맑은 고딕"/>
               </a:rPr>
-              <a:t>라이브러리 목록</a:t>
+              <a:t>“라이브러리에서 SDNN 언급한 논문 찾아줘”</a:t>
             </a:r>
           </a:p>
         </p:txBody>
@@ -9840,7 +9789,7 @@
         <p:spPr>
           <a:xfrm>
             <a:off x="548640" y="2926080"/>
-            <a:ext cx="5440680" cy="914400"/>
+            <a:ext cx="5440680" cy="987552"/>
           </a:xfrm>
           <a:prstGeom prst="roundRect">
             <a:avLst>
@@ -9886,7 +9835,7 @@
         <p:spPr>
           <a:xfrm>
             <a:off x="822959" y="3054096"/>
-            <a:ext cx="4937760" cy="365760"/>
+            <a:ext cx="4937760" cy="320040"/>
           </a:xfrm>
           <a:prstGeom prst="rect">
             <a:avLst/>
@@ -9905,14 +9854,14 @@
               </a:spcAft>
             </a:pPr>
             <a:r>
-              <a:rPr sz="1400" b="1">
+              <a:rPr sz="1300" b="1">
                 <a:solidFill>
                   <a:srgbClr val="0B5C5A"/>
                 </a:solidFill>
-                <a:latin typeface="Consolas"/>
+                <a:latin typeface="맑은 고딕"/>
                 <a:ea typeface="맑은 고딕"/>
               </a:rPr>
-              <a:t>search &lt;단어…&gt;</a:t>
+              <a:t>요약 다시 보기</a:t>
             </a:r>
           </a:p>
         </p:txBody>
@@ -9925,8 +9874,8 @@
         </p:nvSpPr>
         <p:spPr>
           <a:xfrm>
-            <a:off x="822959" y="3429000"/>
-            <a:ext cx="4937760" cy="365760"/>
+            <a:off x="822959" y="3401568"/>
+            <a:ext cx="4937760" cy="411480"/>
           </a:xfrm>
           <a:prstGeom prst="rect">
             <a:avLst/>
@@ -9945,14 +9894,14 @@
               </a:spcAft>
             </a:pPr>
             <a:r>
-              <a:rPr sz="1400" b="0">
+              <a:rPr sz="1600" b="0">
                 <a:solidFill>
                   <a:srgbClr val="1F292B"/>
                 </a:solidFill>
                 <a:latin typeface="맑은 고딕"/>
                 <a:ea typeface="맑은 고딕"/>
               </a:rPr>
-              <a:t>제목·초록·요약·본문 검색</a:t>
+              <a:t>“Sampath2026adaptive 요약 HTML로 열어줘”</a:t>
             </a:r>
           </a:p>
         </p:txBody>
@@ -9966,7 +9915,7 @@
         <p:spPr>
           <a:xfrm>
             <a:off x="6172200" y="2926080"/>
-            <a:ext cx="5440680" cy="914400"/>
+            <a:ext cx="5440680" cy="987552"/>
           </a:xfrm>
           <a:prstGeom prst="roundRect">
             <a:avLst>
@@ -10012,7 +9961,7 @@
         <p:spPr>
           <a:xfrm>
             <a:off x="6446520" y="3054096"/>
-            <a:ext cx="4937760" cy="365760"/>
+            <a:ext cx="4937760" cy="320040"/>
           </a:xfrm>
           <a:prstGeom prst="rect">
             <a:avLst/>
@@ -10031,14 +9980,14 @@
               </a:spcAft>
             </a:pPr>
             <a:r>
-              <a:rPr sz="1400" b="1">
+              <a:rPr sz="1300" b="1">
                 <a:solidFill>
                   <a:srgbClr val="0B5C5A"/>
                 </a:solidFill>
-                <a:latin typeface="Consolas"/>
+                <a:latin typeface="맑은 고딕"/>
                 <a:ea typeface="맑은 고딕"/>
               </a:rPr>
-              <a:t>show &lt;citekey&gt;</a:t>
+              <a:t>요약 고치기</a:t>
             </a:r>
           </a:p>
         </p:txBody>
@@ -10051,8 +10000,8 @@
         </p:nvSpPr>
         <p:spPr>
           <a:xfrm>
-            <a:off x="6446520" y="3429000"/>
-            <a:ext cx="4937760" cy="365760"/>
+            <a:off x="6446520" y="3401568"/>
+            <a:ext cx="4937760" cy="411480"/>
           </a:xfrm>
           <a:prstGeom prst="rect">
             <a:avLst/>
@@ -10071,14 +10020,14 @@
               </a:spcAft>
             </a:pPr>
             <a:r>
-              <a:rPr sz="1400" b="0">
+              <a:rPr sz="1600" b="0">
                 <a:solidFill>
                   <a:srgbClr val="1F292B"/>
                 </a:solidFill>
                 <a:latin typeface="맑은 고딕"/>
                 <a:ea typeface="맑은 고딕"/>
               </a:rPr>
-              <a:t>서지 정보와 파일 목록</a:t>
+              <a:t>“Limitations 부분 더 자세히 써줘”</a:t>
             </a:r>
           </a:p>
         </p:txBody>
@@ -10091,8 +10040,8 @@
         </p:nvSpPr>
         <p:spPr>
           <a:xfrm>
-            <a:off x="548640" y="4023360"/>
-            <a:ext cx="5440680" cy="914400"/>
+            <a:off x="548640" y="4069080"/>
+            <a:ext cx="5440680" cy="987552"/>
           </a:xfrm>
           <a:prstGeom prst="roundRect">
             <a:avLst>
@@ -10137,8 +10086,8 @@
         </p:nvSpPr>
         <p:spPr>
           <a:xfrm>
-            <a:off x="822959" y="4151376"/>
-            <a:ext cx="4937760" cy="365760"/>
+            <a:off x="822959" y="4197096"/>
+            <a:ext cx="4937760" cy="320040"/>
           </a:xfrm>
           <a:prstGeom prst="rect">
             <a:avLst/>
@@ -10157,14 +10106,14 @@
               </a:spcAft>
             </a:pPr>
             <a:r>
-              <a:rPr sz="1400" b="1">
+              <a:rPr sz="1300" b="1">
                 <a:solidFill>
                   <a:srgbClr val="0B5C5A"/>
                 </a:solidFill>
-                <a:latin typeface="Consolas"/>
+                <a:latin typeface="맑은 고딕"/>
                 <a:ea typeface="맑은 고딕"/>
               </a:rPr>
-              <a:t>cite &lt;원고.md&gt; [--style apa|ieee] [--table]</a:t>
+              <a:t>수치 확인</a:t>
             </a:r>
           </a:p>
         </p:txBody>
@@ -10177,8 +10126,8 @@
         </p:nvSpPr>
         <p:spPr>
           <a:xfrm>
-            <a:off x="822959" y="4526280"/>
-            <a:ext cx="4937760" cy="365760"/>
+            <a:off x="822959" y="4544568"/>
+            <a:ext cx="4937760" cy="411480"/>
           </a:xfrm>
           <a:prstGeom prst="rect">
             <a:avLst/>
@@ -10197,14 +10146,14 @@
               </a:spcAft>
             </a:pPr>
             <a:r>
-              <a:rPr sz="1400" b="0">
+              <a:rPr sz="1600" b="0">
                 <a:solidFill>
                   <a:srgbClr val="1F292B"/>
                 </a:solidFill>
                 <a:latin typeface="맑은 고딕"/>
                 <a:ea typeface="맑은 고딕"/>
               </a:rPr>
-              <a:t>인용 키 → 본문 인용 + 참고문헌</a:t>
+              <a:t>“이 수치 원문 몇 쪽인지 보여줘”</a:t>
             </a:r>
           </a:p>
         </p:txBody>
@@ -10217,8 +10166,8 @@
         </p:nvSpPr>
         <p:spPr>
           <a:xfrm>
-            <a:off x="6172200" y="4023360"/>
-            <a:ext cx="5440680" cy="914400"/>
+            <a:off x="6172200" y="4069080"/>
+            <a:ext cx="5440680" cy="987552"/>
           </a:xfrm>
           <a:prstGeom prst="roundRect">
             <a:avLst>
@@ -10263,8 +10212,8 @@
         </p:nvSpPr>
         <p:spPr>
           <a:xfrm>
-            <a:off x="6446520" y="4151376"/>
-            <a:ext cx="4937760" cy="365760"/>
+            <a:off x="6446520" y="4197096"/>
+            <a:ext cx="4937760" cy="320040"/>
           </a:xfrm>
           <a:prstGeom prst="rect">
             <a:avLst/>
@@ -10283,14 +10232,14 @@
               </a:spcAft>
             </a:pPr>
             <a:r>
-              <a:rPr sz="1400" b="1">
+              <a:rPr sz="1300" b="1">
                 <a:solidFill>
                   <a:srgbClr val="0B5C5A"/>
                 </a:solidFill>
-                <a:latin typeface="Consolas"/>
+                <a:latin typeface="맑은 고딕"/>
                 <a:ea typeface="맑은 고딕"/>
               </a:rPr>
-              <a:t>render [citekey]</a:t>
+              <a:t>출처 찾아 인용</a:t>
             </a:r>
           </a:p>
         </p:txBody>
@@ -10303,8 +10252,8 @@
         </p:nvSpPr>
         <p:spPr>
           <a:xfrm>
-            <a:off x="6446520" y="4526280"/>
-            <a:ext cx="4937760" cy="365760"/>
+            <a:off x="6446520" y="4544568"/>
+            <a:ext cx="4937760" cy="411480"/>
           </a:xfrm>
           <a:prstGeom prst="rect">
             <a:avLst/>
@@ -10323,14 +10272,14 @@
               </a:spcAft>
             </a:pPr>
             <a:r>
-              <a:rPr sz="1400" b="0">
+              <a:rPr sz="1600" b="0">
                 <a:solidFill>
                   <a:srgbClr val="1F292B"/>
                 </a:solidFill>
                 <a:latin typeface="맑은 고딕"/>
                 <a:ea typeface="맑은 고딕"/>
               </a:rPr>
-              <a:t>요약 노트 → HTML 페이지</a:t>
+              <a:t>“이 문장에 맞는 출처 찾아서 인용 달아줘”</a:t>
             </a:r>
           </a:p>
         </p:txBody>
@@ -10343,8 +10292,8 @@
         </p:nvSpPr>
         <p:spPr>
           <a:xfrm>
-            <a:off x="548640" y="5120640"/>
-            <a:ext cx="5440680" cy="914400"/>
+            <a:off x="548640" y="5212080"/>
+            <a:ext cx="5440680" cy="987552"/>
           </a:xfrm>
           <a:prstGeom prst="roundRect">
             <a:avLst>
@@ -10389,8 +10338,8 @@
         </p:nvSpPr>
         <p:spPr>
           <a:xfrm>
-            <a:off x="822959" y="5248655"/>
-            <a:ext cx="4937760" cy="365760"/>
+            <a:off x="822959" y="5340096"/>
+            <a:ext cx="4937760" cy="320040"/>
           </a:xfrm>
           <a:prstGeom prst="rect">
             <a:avLst/>
@@ -10409,14 +10358,14 @@
               </a:spcAft>
             </a:pPr>
             <a:r>
-              <a:rPr sz="1400" b="1">
+              <a:rPr sz="1300" b="1">
                 <a:solidFill>
                   <a:srgbClr val="0B5C5A"/>
                 </a:solidFill>
-                <a:latin typeface="Consolas"/>
+                <a:latin typeface="맑은 고딕"/>
                 <a:ea typeface="맑은 고딕"/>
               </a:rPr>
-              <a:t>rebuild</a:t>
+              <a:t>PDF 대기 목록</a:t>
             </a:r>
           </a:p>
         </p:txBody>
@@ -10429,8 +10378,8 @@
         </p:nvSpPr>
         <p:spPr>
           <a:xfrm>
-            <a:off x="822959" y="5623559"/>
-            <a:ext cx="4937760" cy="365760"/>
+            <a:off x="822959" y="5687568"/>
+            <a:ext cx="4937760" cy="411480"/>
           </a:xfrm>
           <a:prstGeom prst="rect">
             <a:avLst/>
@@ -10449,14 +10398,140 @@
               </a:spcAft>
             </a:pPr>
             <a:r>
-              <a:rPr sz="1400" b="0">
+              <a:rPr sz="1600" b="0">
                 <a:solidFill>
                   <a:srgbClr val="1F292B"/>
                 </a:solidFill>
                 <a:latin typeface="맑은 고딕"/>
                 <a:ea typeface="맑은 고딕"/>
               </a:rPr>
-              <a:t>library.json · library.bib 다시 만들기</a:t>
+              <a:t>“PDF 기다리는 논문 목록 보여줘”</a:t>
+            </a:r>
+          </a:p>
+        </p:txBody>
+      </p:sp>
+      <p:sp>
+        <p:nvSpPr>
+          <p:cNvPr id="25" name="Rounded Rectangle 24"/>
+          <p:cNvSpPr/>
+          <p:nvPr/>
+        </p:nvSpPr>
+        <p:spPr>
+          <a:xfrm>
+            <a:off x="6172200" y="5212080"/>
+            <a:ext cx="5440680" cy="987552"/>
+          </a:xfrm>
+          <a:prstGeom prst="roundRect">
+            <a:avLst>
+              <a:gd name="adj" fmla="val 6000"/>
+            </a:avLst>
+          </a:prstGeom>
+          <a:solidFill>
+            <a:srgbClr val="F1F7F6"/>
+          </a:solidFill>
+          <a:ln>
+            <a:noFill/>
+          </a:ln>
+          <a:effectLst/>
+        </p:spPr>
+        <p:style>
+          <a:lnRef idx="1">
+            <a:schemeClr val="accent1"/>
+          </a:lnRef>
+          <a:fillRef idx="3">
+            <a:schemeClr val="accent1"/>
+          </a:fillRef>
+          <a:effectRef idx="2">
+            <a:schemeClr val="accent1"/>
+          </a:effectRef>
+          <a:fontRef idx="minor">
+            <a:schemeClr val="lt1"/>
+          </a:fontRef>
+        </p:style>
+        <p:txBody>
+          <a:bodyPr rtlCol="0" anchor="ctr"/>
+          <a:lstStyle/>
+          <a:p>
+            <a:pPr algn="ctr"/>
+          </a:p>
+        </p:txBody>
+      </p:sp>
+      <p:sp>
+        <p:nvSpPr>
+          <p:cNvPr id="26" name="TextBox 25"/>
+          <p:cNvSpPr txBox="1"/>
+          <p:nvPr/>
+        </p:nvSpPr>
+        <p:spPr>
+          <a:xfrm>
+            <a:off x="6446520" y="5340096"/>
+            <a:ext cx="4937760" cy="320040"/>
+          </a:xfrm>
+          <a:prstGeom prst="rect">
+            <a:avLst/>
+          </a:prstGeom>
+          <a:noFill/>
+        </p:spPr>
+        <p:txBody>
+          <a:bodyPr wrap="square" lIns="0" rIns="0" tIns="0" bIns="0" anchor="t">
+            <a:spAutoFit/>
+          </a:bodyPr>
+          <a:lstStyle/>
+          <a:p>
+            <a:pPr algn="l">
+              <a:spcAft>
+                <a:spcPts val="600"/>
+              </a:spcAft>
+            </a:pPr>
+            <a:r>
+              <a:rPr sz="1300" b="1">
+                <a:solidFill>
+                  <a:srgbClr val="0B5C5A"/>
+                </a:solidFill>
+                <a:latin typeface="맑은 고딕"/>
+                <a:ea typeface="맑은 고딕"/>
+              </a:rPr>
+              <a:t>스킬 업데이트</a:t>
+            </a:r>
+          </a:p>
+        </p:txBody>
+      </p:sp>
+      <p:sp>
+        <p:nvSpPr>
+          <p:cNvPr id="27" name="TextBox 26"/>
+          <p:cNvSpPr txBox="1"/>
+          <p:nvPr/>
+        </p:nvSpPr>
+        <p:spPr>
+          <a:xfrm>
+            <a:off x="6446520" y="5687568"/>
+            <a:ext cx="4937760" cy="411480"/>
+          </a:xfrm>
+          <a:prstGeom prst="rect">
+            <a:avLst/>
+          </a:prstGeom>
+          <a:noFill/>
+        </p:spPr>
+        <p:txBody>
+          <a:bodyPr wrap="square" lIns="0" rIns="0" tIns="0" bIns="0" anchor="t">
+            <a:spAutoFit/>
+          </a:bodyPr>
+          <a:lstStyle/>
+          <a:p>
+            <a:pPr algn="l">
+              <a:spcAft>
+                <a:spcPts val="600"/>
+              </a:spcAft>
+            </a:pPr>
+            <a:r>
+              <a:rPr sz="1600" b="0">
+                <a:solidFill>
+                  <a:srgbClr val="1F292B"/>
+                </a:solidFill>
+                <a:latin typeface="맑은 고딕"/>
+                <a:ea typeface="맑은 고딕"/>
+              </a:rPr>
+              <a:t>“paper-summary 최신 버전으로 업데이트해줘”</a:t>
             </a:r>
           </a:p>
         </p:txBody>
@@ -11294,7 +11369,7 @@
                 <a:latin typeface="맑은 고딕"/>
                 <a:ea typeface="맑은 고딕"/>
               </a:rPr>
-              <a:t>git -C ~/.claude/skills/paper-summary pull</a:t>
+              <a:t>“paper-summary 스킬 최신 버전으로 업데이트해줘”</a:t>
             </a:r>
           </a:p>
         </p:txBody>

</xml_diff>

<commit_message>
Support policy reports and web pages
- add <web URL> saves page text, title, site, date and access date
- PDFs without a DOI default to reports; set fills issuing body,
  year, report number, publisher and URL; rename changes a citekey
- organization and Korean author names are kept as written;
  citekeys can contain Korean (e.g. STEPI2025인공지능)
- APA/IEEE/BibTeX formats for reports, books and web pages;
  Korean figure captions (<그림 2-1>) are extracted
- SKILL.md adds a web-search step for government, think-tank and
  international-organization sources; README and guide updated

Co-Authored-By: Claude Opus 5.5 <noreply@anthropic.com>
</commit_message>
<xml_diff>
--- a/docs/paper-summary_사용가이드.pptx
+++ b/docs/paper-summary_사용가이드.pptx
@@ -14,6 +14,7 @@
     <p:sldId id="262" r:id="rId14"/>
     <p:sldId id="263" r:id="rId15"/>
     <p:sldId id="264" r:id="rId16"/>
+    <p:sldId id="265" r:id="rId17"/>
   </p:sldIdLst>
   <p:sldSz cx="12191695" cy="6858000" type="screen4x3"/>
   <p:notesSz cx="6858000" cy="9144000"/>
@@ -535,6 +536,76 @@
 </p:notes>
 </file>
 
+<file path=ppt/notesSlides/notesSlide10.xml><?xml version="1.0" encoding="utf-8"?>
+<p:notes xmlns:a="http://schemas.openxmlformats.org/drawingml/2006/main" xmlns:p="http://schemas.openxmlformats.org/presentationml/2006/main" xmlns:r="http://schemas.openxmlformats.org/officeDocument/2006/relationships">
+  <p:cSld>
+    <p:spTree>
+      <p:nvGrpSpPr>
+        <p:cNvPr id="1" name=""/>
+        <p:cNvGrpSpPr/>
+        <p:nvPr/>
+      </p:nvGrpSpPr>
+      <p:grpSpPr>
+        <a:xfrm>
+          <a:off x="0" y="0"/>
+          <a:ext cx="0" cy="0"/>
+          <a:chOff x="0" y="0"/>
+          <a:chExt cx="0" cy="0"/>
+        </a:xfrm>
+      </p:grpSpPr>
+      <p:sp>
+        <p:nvSpPr>
+          <p:cNvPr id="2" name="Slide Image Placeholder 1"/>
+          <p:cNvSpPr>
+            <a:spLocks noGrp="1"/>
+          </p:cNvSpPr>
+          <p:nvPr>
+            <p:ph type="sldImg" idx="2"/>
+          </p:nvPr>
+        </p:nvSpPr>
+        <p:spPr/>
+      </p:sp>
+      <p:sp>
+        <p:nvSpPr>
+          <p:cNvPr id="3" name="Notes Placeholder 2"/>
+          <p:cNvSpPr>
+            <a:spLocks noGrp="1"/>
+          </p:cNvSpPr>
+          <p:nvPr>
+            <p:ph type="body" idx="3" sz="quarter"/>
+          </p:nvPr>
+        </p:nvSpPr>
+        <p:spPr/>
+        <p:txBody>
+          <a:bodyPr/>
+          <a:lstStyle/>
+          <a:p>
+            <a:r>
+              <a:t>질문은 저장소 이슈로 남겨 주세요.</a:t>
+            </a:r>
+          </a:p>
+        </p:txBody>
+      </p:sp>
+      <p:sp>
+        <p:nvSpPr>
+          <p:cNvPr id="4" name="Slide Number Placeholder 3"/>
+          <p:cNvSpPr>
+            <a:spLocks noGrp="1"/>
+          </p:cNvSpPr>
+          <p:nvPr>
+            <p:ph type="sldNum" idx="5" sz="quarter"/>
+          </p:nvPr>
+        </p:nvSpPr>
+        <p:spPr/>
+      </p:sp>
+    </p:spTree>
+  </p:cSld>
+  <p:clrMapOvr>
+    <a:masterClrMapping/>
+  </p:clrMapOvr>
+</p:notes>
+</file>
+
 <file path=ppt/notesSlides/notesSlide2.xml><?xml version="1.0" encoding="utf-8"?>
 <p:notes xmlns:a="http://schemas.openxmlformats.org/drawingml/2006/main" xmlns:p="http://schemas.openxmlformats.org/presentationml/2006/main" xmlns:r="http://schemas.openxmlformats.org/officeDocument/2006/relationships">
   <p:cSld>
@@ -930,7 +1001,7 @@
           <a:lstStyle/>
           <a:p>
             <a:r>
-              <a:t>처음에 /paper-summary를 붙이면 이 스킬을 확실히 씁니다. 붙이지 않아도 논문·참고문헌 관련 말이면 Claude가 알아서 고릅니다.</a:t>
+              <a:t>언론 기사나 재게시 페이지는 원문을 찾는 실마리로만 쓰고, 인용은 원 발행 기관 자료로 합니다. 로그인이 필요한 PDF는 내려받아 경로를 알려 주면 됩니다.</a:t>
             </a:r>
           </a:p>
         </p:txBody>
@@ -1000,7 +1071,7 @@
           <a:lstStyle/>
           <a:p>
             <a:r>
-              <a:t>citekey는 제1저자 성 + 연도 + 제목 첫 단어. 같은 DOI를 다시 넣으면 기존 폴더를 갱신합니다.</a:t>
+              <a:t>처음에 /paper-summary를 붙이면 이 스킬을 확실히 씁니다. 붙이지 않아도 논문·참고문헌 관련 말이면 Claude가 알아서 고릅니다.</a:t>
             </a:r>
           </a:p>
         </p:txBody>
@@ -1070,7 +1141,7 @@
           <a:lstStyle/>
           <a:p>
             <a:r>
-              <a:t>질문은 저장소 이슈로 남겨 주세요.</a:t>
+              <a:t>citekey는 제1저자 성 + 연도 + 제목 첫 단어. 같은 DOI를 다시 넣으면 기존 폴더를 갱신합니다.</a:t>
             </a:r>
           </a:p>
         </p:txBody>
@@ -4412,6 +4483,238 @@
 </p:sld>
 </file>
 
+<file path=ppt/slides/slide10.xml><?xml version="1.0" encoding="utf-8"?>
+<p:sld xmlns:a="http://schemas.openxmlformats.org/drawingml/2006/main" xmlns:p="http://schemas.openxmlformats.org/presentationml/2006/main" xmlns:r="http://schemas.openxmlformats.org/officeDocument/2006/relationships">
+  <p:cSld>
+    <p:bg>
+      <p:bgPr>
+        <a:solidFill>
+          <a:srgbClr val="0E2F2E"/>
+        </a:solidFill>
+        <a:effectLst/>
+      </p:bgPr>
+    </p:bg>
+    <p:spTree>
+      <p:nvGrpSpPr>
+        <p:cNvPr id="1" name=""/>
+        <p:cNvGrpSpPr/>
+        <p:nvPr/>
+      </p:nvGrpSpPr>
+      <p:grpSpPr/>
+      <p:sp>
+        <p:nvSpPr>
+          <p:cNvPr id="2" name="TextBox 1"/>
+          <p:cNvSpPr txBox="1"/>
+          <p:nvPr/>
+        </p:nvSpPr>
+        <p:spPr>
+          <a:xfrm>
+            <a:off x="822960" y="1828800"/>
+            <a:ext cx="10515600" cy="914400"/>
+          </a:xfrm>
+          <a:prstGeom prst="rect">
+            <a:avLst/>
+          </a:prstGeom>
+          <a:noFill/>
+        </p:spPr>
+        <p:txBody>
+          <a:bodyPr wrap="square" lIns="0" rIns="0" tIns="0" bIns="0" anchor="t">
+            <a:spAutoFit/>
+          </a:bodyPr>
+          <a:lstStyle/>
+          <a:p>
+            <a:pPr algn="l">
+              <a:spcAft>
+                <a:spcPts val="600"/>
+              </a:spcAft>
+            </a:pPr>
+            <a:r>
+              <a:rPr sz="4000" b="1">
+                <a:solidFill>
+                  <a:srgbClr val="FFFFFF"/>
+                </a:solidFill>
+                <a:latin typeface="맑은 고딕"/>
+                <a:ea typeface="맑은 고딕"/>
+              </a:rPr>
+              <a:t>지금 시작하기</a:t>
+            </a:r>
+          </a:p>
+        </p:txBody>
+      </p:sp>
+      <p:sp>
+        <p:nvSpPr>
+          <p:cNvPr id="3" name="TextBox 2"/>
+          <p:cNvSpPr txBox="1"/>
+          <p:nvPr/>
+        </p:nvSpPr>
+        <p:spPr>
+          <a:xfrm>
+            <a:off x="822960" y="2880360"/>
+            <a:ext cx="10515600" cy="548640"/>
+          </a:xfrm>
+          <a:prstGeom prst="rect">
+            <a:avLst/>
+          </a:prstGeom>
+          <a:noFill/>
+        </p:spPr>
+        <p:txBody>
+          <a:bodyPr wrap="square" lIns="0" rIns="0" tIns="0" bIns="0" anchor="t">
+            <a:spAutoFit/>
+          </a:bodyPr>
+          <a:lstStyle/>
+          <a:p>
+            <a:pPr algn="l">
+              <a:spcAft>
+                <a:spcPts val="600"/>
+              </a:spcAft>
+            </a:pPr>
+            <a:r>
+              <a:rPr sz="1800" b="0">
+                <a:solidFill>
+                  <a:srgbClr val="C9DDDA"/>
+                </a:solidFill>
+                <a:latin typeface="맑은 고딕"/>
+                <a:ea typeface="맑은 고딕"/>
+              </a:rPr>
+              <a:t>Claude Code에서 이렇게 말해 보세요</a:t>
+            </a:r>
+          </a:p>
+        </p:txBody>
+      </p:sp>
+      <p:sp>
+        <p:nvSpPr>
+          <p:cNvPr id="4" name="Rounded Rectangle 3"/>
+          <p:cNvSpPr/>
+          <p:nvPr/>
+        </p:nvSpPr>
+        <p:spPr>
+          <a:xfrm>
+            <a:off x="822960" y="3566160"/>
+            <a:ext cx="10515600" cy="914400"/>
+          </a:xfrm>
+          <a:prstGeom prst="roundRect">
+            <a:avLst>
+              <a:gd name="adj" fmla="val 6000"/>
+            </a:avLst>
+          </a:prstGeom>
+          <a:solidFill>
+            <a:srgbClr val="174543"/>
+          </a:solidFill>
+          <a:ln>
+            <a:noFill/>
+          </a:ln>
+          <a:effectLst/>
+        </p:spPr>
+        <p:style>
+          <a:lnRef idx="1">
+            <a:schemeClr val="accent1"/>
+          </a:lnRef>
+          <a:fillRef idx="3">
+            <a:schemeClr val="accent1"/>
+          </a:fillRef>
+          <a:effectRef idx="2">
+            <a:schemeClr val="accent1"/>
+          </a:effectRef>
+          <a:fontRef idx="minor">
+            <a:schemeClr val="lt1"/>
+          </a:fontRef>
+        </p:style>
+        <p:txBody>
+          <a:bodyPr rtlCol="0" anchor="ctr"/>
+          <a:lstStyle/>
+          <a:p>
+            <a:pPr algn="ctr"/>
+          </a:p>
+        </p:txBody>
+      </p:sp>
+      <p:sp>
+        <p:nvSpPr>
+          <p:cNvPr id="5" name="TextBox 4"/>
+          <p:cNvSpPr txBox="1"/>
+          <p:nvPr/>
+        </p:nvSpPr>
+        <p:spPr>
+          <a:xfrm>
+            <a:off x="1097280" y="3767328"/>
+            <a:ext cx="10058400" cy="548640"/>
+          </a:xfrm>
+          <a:prstGeom prst="rect">
+            <a:avLst/>
+          </a:prstGeom>
+          <a:noFill/>
+        </p:spPr>
+        <p:txBody>
+          <a:bodyPr wrap="square" lIns="0" rIns="0" tIns="0" bIns="0" anchor="t">
+            <a:spAutoFit/>
+          </a:bodyPr>
+          <a:lstStyle/>
+          <a:p>
+            <a:pPr algn="l">
+              <a:spcAft>
+                <a:spcPts val="600"/>
+              </a:spcAft>
+            </a:pPr>
+            <a:r>
+              <a:rPr sz="2200" b="1">
+                <a:solidFill>
+                  <a:srgbClr val="FFFFFF"/>
+                </a:solidFill>
+                <a:latin typeface="맑은 고딕"/>
+                <a:ea typeface="맑은 고딕"/>
+              </a:rPr>
+              <a:t>/paper-summary  관심 주제를 정리해줘</a:t>
+            </a:r>
+          </a:p>
+        </p:txBody>
+      </p:sp>
+      <p:sp>
+        <p:nvSpPr>
+          <p:cNvPr id="6" name="TextBox 5"/>
+          <p:cNvSpPr txBox="1"/>
+          <p:nvPr/>
+        </p:nvSpPr>
+        <p:spPr>
+          <a:xfrm>
+            <a:off x="822960" y="5212080"/>
+            <a:ext cx="10515600" cy="365760"/>
+          </a:xfrm>
+          <a:prstGeom prst="rect">
+            <a:avLst/>
+          </a:prstGeom>
+          <a:noFill/>
+        </p:spPr>
+        <p:txBody>
+          <a:bodyPr wrap="square" lIns="0" rIns="0" tIns="0" bIns="0" anchor="t">
+            <a:spAutoFit/>
+          </a:bodyPr>
+          <a:lstStyle/>
+          <a:p>
+            <a:pPr algn="l">
+              <a:spcAft>
+                <a:spcPts val="600"/>
+              </a:spcAft>
+            </a:pPr>
+            <a:r>
+              <a:rPr sz="1400" b="0">
+                <a:solidFill>
+                  <a:srgbClr val="8FD3C8"/>
+                </a:solidFill>
+                <a:latin typeface="Consolas"/>
+                <a:ea typeface="맑은 고딕"/>
+              </a:rPr>
+              <a:t>github.com/emilyJ7/paper-summary  ·  MIT License</a:t>
+            </a:r>
+          </a:p>
+        </p:txBody>
+      </p:sp>
+    </p:spTree>
+  </p:cSld>
+  <p:clrMapOvr>
+    <a:masterClrMapping/>
+  </p:clrMapOvr>
+</p:sld>
+</file>
+
 <file path=ppt/slides/slide2.xml><?xml version="1.0" encoding="utf-8"?>
 <p:sld xmlns:a="http://schemas.openxmlformats.org/drawingml/2006/main" xmlns:p="http://schemas.openxmlformats.org/presentationml/2006/main" xmlns:r="http://schemas.openxmlformats.org/officeDocument/2006/relationships">
   <p:cSld>
@@ -9483,7 +9786,7 @@
                 <a:latin typeface="맑은 고딕"/>
                 <a:ea typeface="맑은 고딕"/>
               </a:rPr>
-              <a:t>이럴 땐 이렇게 말하세요</a:t>
+              <a:t>④ 정책 보고서·보도자료도 같은 방식으로</a:t>
             </a:r>
           </a:p>
         </p:txBody>
@@ -9523,7 +9826,7 @@
                 <a:latin typeface="맑은 고딕"/>
                 <a:ea typeface="맑은 고딕"/>
               </a:rPr>
-              <a:t>명령어를 외울 필요 없이 — Claude가 알아서 실행합니다</a:t>
+              <a:t>“/paper-summary AI 인재정책 관련 국내외 정책 보고서와 논문 조사해줘”</a:t>
             </a:r>
           </a:p>
         </p:txBody>
@@ -9537,7 +9840,7 @@
         <p:spPr>
           <a:xfrm>
             <a:off x="548640" y="1783080"/>
-            <a:ext cx="5440680" cy="987552"/>
+            <a:ext cx="2331720" cy="1737360"/>
           </a:xfrm>
           <a:prstGeom prst="roundRect">
             <a:avLst>
@@ -9582,8 +9885,8 @@
         </p:nvSpPr>
         <p:spPr>
           <a:xfrm>
-            <a:off x="822959" y="1911095"/>
-            <a:ext cx="4937760" cy="320040"/>
+            <a:off x="777240" y="1938528"/>
+            <a:ext cx="1920240" cy="365760"/>
           </a:xfrm>
           <a:prstGeom prst="rect">
             <a:avLst/>
@@ -9602,14 +9905,14 @@
               </a:spcAft>
             </a:pPr>
             <a:r>
-              <a:rPr sz="1300" b="1">
-                <a:solidFill>
-                  <a:srgbClr val="0B5C5A"/>
-                </a:solidFill>
-                <a:latin typeface="맑은 고딕"/>
-                <a:ea typeface="맑은 고딕"/>
-              </a:rPr>
-              <a:t>가진 PDF 정리</a:t>
+              <a:rPr sz="1700" b="1">
+                <a:solidFill>
+                  <a:srgbClr val="0E2F2E"/>
+                </a:solidFill>
+                <a:latin typeface="맑은 고딕"/>
+                <a:ea typeface="맑은 고딕"/>
+              </a:rPr>
+              <a:t>국책연구기관</a:t>
             </a:r>
           </a:p>
         </p:txBody>
@@ -9622,8 +9925,8 @@
         </p:nvSpPr>
         <p:spPr>
           <a:xfrm>
-            <a:off x="822959" y="2258568"/>
-            <a:ext cx="4937760" cy="411480"/>
+            <a:off x="777240" y="2395728"/>
+            <a:ext cx="1965960" cy="1005840"/>
           </a:xfrm>
           <a:prstGeom prst="rect">
             <a:avLst/>
@@ -9638,18 +9941,35 @@
           <a:p>
             <a:pPr algn="l">
               <a:spcAft>
-                <a:spcPts val="600"/>
-              </a:spcAft>
-            </a:pPr>
-            <a:r>
-              <a:rPr sz="1600" b="0">
+                <a:spcPts val="200"/>
+              </a:spcAft>
+            </a:pPr>
+            <a:r>
+              <a:rPr sz="1300" b="0">
                 <a:solidFill>
                   <a:srgbClr val="1F292B"/>
                 </a:solidFill>
                 <a:latin typeface="맑은 고딕"/>
                 <a:ea typeface="맑은 고딕"/>
               </a:rPr>
-              <a:t>“Downloads 폴더의 paper.pdf 논문 요약해줘”</a:t>
+              <a:t>KDI · STEPI · KISTEP</a:t>
+            </a:r>
+          </a:p>
+          <a:p>
+            <a:pPr algn="l">
+              <a:spcAft>
+                <a:spcPts val="200"/>
+              </a:spcAft>
+            </a:pPr>
+            <a:r>
+              <a:rPr sz="1300" b="0">
+                <a:solidFill>
+                  <a:srgbClr val="1F292B"/>
+                </a:solidFill>
+                <a:latin typeface="맑은 고딕"/>
+                <a:ea typeface="맑은 고딕"/>
+              </a:rPr>
+              <a:t>입법조사처 · 예산정책처</a:t>
             </a:r>
           </a:p>
         </p:txBody>
@@ -9662,8 +9982,8 @@
         </p:nvSpPr>
         <p:spPr>
           <a:xfrm>
-            <a:off x="6172200" y="1783080"/>
-            <a:ext cx="5440680" cy="987552"/>
+            <a:off x="3063240" y="1783080"/>
+            <a:ext cx="2331720" cy="1737360"/>
           </a:xfrm>
           <a:prstGeom prst="roundRect">
             <a:avLst>
@@ -9708,8 +10028,8 @@
         </p:nvSpPr>
         <p:spPr>
           <a:xfrm>
-            <a:off x="6446520" y="1911095"/>
-            <a:ext cx="4937760" cy="320040"/>
+            <a:off x="3291840" y="1938528"/>
+            <a:ext cx="1920240" cy="365760"/>
           </a:xfrm>
           <a:prstGeom prst="rect">
             <a:avLst/>
@@ -9728,14 +10048,14 @@
               </a:spcAft>
             </a:pPr>
             <a:r>
-              <a:rPr sz="1300" b="1">
-                <a:solidFill>
-                  <a:srgbClr val="0B5C5A"/>
-                </a:solidFill>
-                <a:latin typeface="맑은 고딕"/>
-                <a:ea typeface="맑은 고딕"/>
-              </a:rPr>
-              <a:t>저장한 논문 찾기</a:t>
+              <a:rPr sz="1700" b="1">
+                <a:solidFill>
+                  <a:srgbClr val="0E2F2E"/>
+                </a:solidFill>
+                <a:latin typeface="맑은 고딕"/>
+                <a:ea typeface="맑은 고딕"/>
+              </a:rPr>
+              <a:t>정부</a:t>
             </a:r>
           </a:p>
         </p:txBody>
@@ -9748,8 +10068,8 @@
         </p:nvSpPr>
         <p:spPr>
           <a:xfrm>
-            <a:off x="6446520" y="2258568"/>
-            <a:ext cx="4937760" cy="411480"/>
+            <a:off x="3291840" y="2395728"/>
+            <a:ext cx="1965960" cy="1005840"/>
           </a:xfrm>
           <a:prstGeom prst="rect">
             <a:avLst/>
@@ -9764,18 +10084,35 @@
           <a:p>
             <a:pPr algn="l">
               <a:spcAft>
-                <a:spcPts val="600"/>
-              </a:spcAft>
-            </a:pPr>
-            <a:r>
-              <a:rPr sz="1600" b="0">
+                <a:spcPts val="200"/>
+              </a:spcAft>
+            </a:pPr>
+            <a:r>
+              <a:rPr sz="1300" b="0">
                 <a:solidFill>
                   <a:srgbClr val="1F292B"/>
                 </a:solidFill>
                 <a:latin typeface="맑은 고딕"/>
                 <a:ea typeface="맑은 고딕"/>
               </a:rPr>
-              <a:t>“라이브러리에서 SDNN 언급한 논문 찾아줘”</a:t>
+              <a:t>부처 누리집 · 정책브리핑</a:t>
+            </a:r>
+          </a:p>
+          <a:p>
+            <a:pPr algn="l">
+              <a:spcAft>
+                <a:spcPts val="200"/>
+              </a:spcAft>
+            </a:pPr>
+            <a:r>
+              <a:rPr sz="1300" b="0">
+                <a:solidFill>
+                  <a:srgbClr val="1F292B"/>
+                </a:solidFill>
+                <a:latin typeface="맑은 고딕"/>
+                <a:ea typeface="맑은 고딕"/>
+              </a:rPr>
+              <a:t>보도자료 · 법령정보</a:t>
             </a:r>
           </a:p>
         </p:txBody>
@@ -9788,8 +10125,8 @@
         </p:nvSpPr>
         <p:spPr>
           <a:xfrm>
-            <a:off x="548640" y="2926080"/>
-            <a:ext cx="5440680" cy="987552"/>
+            <a:off x="5577840" y="1783080"/>
+            <a:ext cx="2331720" cy="1737360"/>
           </a:xfrm>
           <a:prstGeom prst="roundRect">
             <a:avLst>
@@ -9834,8 +10171,8 @@
         </p:nvSpPr>
         <p:spPr>
           <a:xfrm>
-            <a:off x="822959" y="3054096"/>
-            <a:ext cx="4937760" cy="320040"/>
+            <a:off x="5806440" y="1938528"/>
+            <a:ext cx="1920240" cy="365760"/>
           </a:xfrm>
           <a:prstGeom prst="rect">
             <a:avLst/>
@@ -9854,14 +10191,14 @@
               </a:spcAft>
             </a:pPr>
             <a:r>
-              <a:rPr sz="1300" b="1">
-                <a:solidFill>
-                  <a:srgbClr val="0B5C5A"/>
-                </a:solidFill>
-                <a:latin typeface="맑은 고딕"/>
-                <a:ea typeface="맑은 고딕"/>
-              </a:rPr>
-              <a:t>요약 다시 보기</a:t>
+              <a:rPr sz="1700" b="1">
+                <a:solidFill>
+                  <a:srgbClr val="0E2F2E"/>
+                </a:solidFill>
+                <a:latin typeface="맑은 고딕"/>
+                <a:ea typeface="맑은 고딕"/>
+              </a:rPr>
+              <a:t>국제기구</a:t>
             </a:r>
           </a:p>
         </p:txBody>
@@ -9874,8 +10211,8 @@
         </p:nvSpPr>
         <p:spPr>
           <a:xfrm>
-            <a:off x="822959" y="3401568"/>
-            <a:ext cx="4937760" cy="411480"/>
+            <a:off x="5806440" y="2395728"/>
+            <a:ext cx="1965960" cy="1005840"/>
           </a:xfrm>
           <a:prstGeom prst="rect">
             <a:avLst/>
@@ -9890,18 +10227,35 @@
           <a:p>
             <a:pPr algn="l">
               <a:spcAft>
-                <a:spcPts val="600"/>
-              </a:spcAft>
-            </a:pPr>
-            <a:r>
-              <a:rPr sz="1600" b="0">
+                <a:spcPts val="200"/>
+              </a:spcAft>
+            </a:pPr>
+            <a:r>
+              <a:rPr sz="1300" b="0">
                 <a:solidFill>
                   <a:srgbClr val="1F292B"/>
                 </a:solidFill>
                 <a:latin typeface="맑은 고딕"/>
                 <a:ea typeface="맑은 고딕"/>
               </a:rPr>
-              <a:t>“Sampath2026adaptive 요약 HTML로 열어줘”</a:t>
+              <a:t>OECD · World Bank</a:t>
+            </a:r>
+          </a:p>
+          <a:p>
+            <a:pPr algn="l">
+              <a:spcAft>
+                <a:spcPts val="200"/>
+              </a:spcAft>
+            </a:pPr>
+            <a:r>
+              <a:rPr sz="1300" b="0">
+                <a:solidFill>
+                  <a:srgbClr val="1F292B"/>
+                </a:solidFill>
+                <a:latin typeface="맑은 고딕"/>
+                <a:ea typeface="맑은 고딕"/>
+              </a:rPr>
+              <a:t>IMF · UN · EU</a:t>
             </a:r>
           </a:p>
         </p:txBody>
@@ -9914,8 +10268,8 @@
         </p:nvSpPr>
         <p:spPr>
           <a:xfrm>
-            <a:off x="6172200" y="2926080"/>
-            <a:ext cx="5440680" cy="987552"/>
+            <a:off x="548640" y="3749039"/>
+            <a:ext cx="7360920" cy="2514600"/>
           </a:xfrm>
           <a:prstGeom prst="roundRect">
             <a:avLst>
@@ -9923,7 +10277,186 @@
             </a:avLst>
           </a:prstGeom>
           <a:solidFill>
-            <a:srgbClr val="F1F7F6"/>
+            <a:srgbClr val="FFFFFF"/>
+          </a:solidFill>
+          <a:ln w="12700">
+            <a:solidFill>
+              <a:srgbClr val="D8EEEA"/>
+            </a:solidFill>
+          </a:ln>
+          <a:effectLst/>
+        </p:spPr>
+        <p:style>
+          <a:lnRef idx="1">
+            <a:schemeClr val="accent1"/>
+          </a:lnRef>
+          <a:fillRef idx="3">
+            <a:schemeClr val="accent1"/>
+          </a:fillRef>
+          <a:effectRef idx="2">
+            <a:schemeClr val="accent1"/>
+          </a:effectRef>
+          <a:fontRef idx="minor">
+            <a:schemeClr val="lt1"/>
+          </a:fontRef>
+        </p:style>
+        <p:txBody>
+          <a:bodyPr rtlCol="0" anchor="ctr"/>
+          <a:lstStyle/>
+          <a:p>
+            <a:pPr algn="ctr"/>
+          </a:p>
+        </p:txBody>
+      </p:sp>
+      <p:sp>
+        <p:nvSpPr>
+          <p:cNvPr id="14" name="TextBox 13"/>
+          <p:cNvSpPr txBox="1"/>
+          <p:nvPr/>
+        </p:nvSpPr>
+        <p:spPr>
+          <a:xfrm>
+            <a:off x="777240" y="3886200"/>
+            <a:ext cx="6949440" cy="320040"/>
+          </a:xfrm>
+          <a:prstGeom prst="rect">
+            <a:avLst/>
+          </a:prstGeom>
+          <a:noFill/>
+        </p:spPr>
+        <p:txBody>
+          <a:bodyPr wrap="square" lIns="0" rIns="0" tIns="0" bIns="0" anchor="t">
+            <a:spAutoFit/>
+          </a:bodyPr>
+          <a:lstStyle/>
+          <a:p>
+            <a:pPr algn="l">
+              <a:spcAft>
+                <a:spcPts val="600"/>
+              </a:spcAft>
+            </a:pPr>
+            <a:r>
+              <a:rPr sz="1300" b="1">
+                <a:solidFill>
+                  <a:srgbClr val="0B5C5A"/>
+                </a:solidFill>
+                <a:latin typeface="맑은 고딕"/>
+                <a:ea typeface="맑은 고딕"/>
+              </a:rPr>
+              <a:t>이렇게 말하기</a:t>
+            </a:r>
+          </a:p>
+        </p:txBody>
+      </p:sp>
+      <p:sp>
+        <p:nvSpPr>
+          <p:cNvPr id="15" name="TextBox 14"/>
+          <p:cNvSpPr txBox="1"/>
+          <p:nvPr/>
+        </p:nvSpPr>
+        <p:spPr>
+          <a:xfrm>
+            <a:off x="777240" y="4251960"/>
+            <a:ext cx="6949440" cy="1920240"/>
+          </a:xfrm>
+          <a:prstGeom prst="rect">
+            <a:avLst/>
+          </a:prstGeom>
+          <a:noFill/>
+        </p:spPr>
+        <p:txBody>
+          <a:bodyPr wrap="square" lIns="0" rIns="0" tIns="0" bIns="0" anchor="t">
+            <a:spAutoFit/>
+          </a:bodyPr>
+          <a:lstStyle/>
+          <a:p>
+            <a:pPr algn="l">
+              <a:spcAft>
+                <a:spcPts val="500"/>
+              </a:spcAft>
+            </a:pPr>
+            <a:r>
+              <a:rPr sz="1500" b="0">
+                <a:solidFill>
+                  <a:srgbClr val="1F292B"/>
+                </a:solidFill>
+                <a:latin typeface="맑은 고딕"/>
+                <a:ea typeface="맑은 고딕"/>
+              </a:rPr>
+              <a:t>“이 보고서 정리해줘: &lt;PDF 경로 또는 URL&gt;”</a:t>
+            </a:r>
+          </a:p>
+          <a:p>
+            <a:pPr algn="l">
+              <a:spcAft>
+                <a:spcPts val="500"/>
+              </a:spcAft>
+            </a:pPr>
+            <a:r>
+              <a:rPr sz="1500" b="0">
+                <a:solidFill>
+                  <a:srgbClr val="1F292B"/>
+                </a:solidFill>
+                <a:latin typeface="맑은 고딕"/>
+                <a:ea typeface="맑은 고딕"/>
+              </a:rPr>
+              <a:t>“이 보도자료 정리해줘: &lt;페이지 URL&gt;”</a:t>
+            </a:r>
+          </a:p>
+          <a:p>
+            <a:pPr algn="l">
+              <a:spcAft>
+                <a:spcPts val="500"/>
+              </a:spcAft>
+            </a:pPr>
+            <a:r>
+              <a:rPr sz="1500" b="0">
+                <a:solidFill>
+                  <a:srgbClr val="1F292B"/>
+                </a:solidFill>
+                <a:latin typeface="맑은 고딕"/>
+                <a:ea typeface="맑은 고딕"/>
+              </a:rPr>
+              <a:t>“보고서 번호를 정책연구 2025-07로 고쳐줘”</a:t>
+            </a:r>
+          </a:p>
+          <a:p>
+            <a:pPr algn="l">
+              <a:spcAft>
+                <a:spcPts val="500"/>
+              </a:spcAft>
+            </a:pPr>
+            <a:r>
+              <a:rPr sz="1500" b="0">
+                <a:solidFill>
+                  <a:srgbClr val="1F292B"/>
+                </a:solidFill>
+                <a:latin typeface="맑은 고딕"/>
+                <a:ea typeface="맑은 고딕"/>
+              </a:rPr>
+              <a:t>“인용 키를 STEPI2025인공지능으로 바꿔줘”</a:t>
+            </a:r>
+          </a:p>
+        </p:txBody>
+      </p:sp>
+      <p:sp>
+        <p:nvSpPr>
+          <p:cNvPr id="16" name="Rounded Rectangle 15"/>
+          <p:cNvSpPr/>
+          <p:nvPr/>
+        </p:nvSpPr>
+        <p:spPr>
+          <a:xfrm>
+            <a:off x="8183879" y="1783080"/>
+            <a:ext cx="3474720" cy="4480560"/>
+          </a:xfrm>
+          <a:prstGeom prst="roundRect">
+            <a:avLst>
+              <a:gd name="adj" fmla="val 6000"/>
+            </a:avLst>
+          </a:prstGeom>
+          <a:solidFill>
+            <a:srgbClr val="FDF1DF"/>
           </a:solidFill>
           <a:ln>
             <a:noFill/>
@@ -9954,14 +10487,14 @@
       </p:sp>
       <p:sp>
         <p:nvSpPr>
-          <p:cNvPr id="14" name="TextBox 13"/>
+          <p:cNvPr id="17" name="TextBox 16"/>
           <p:cNvSpPr txBox="1"/>
           <p:nvPr/>
         </p:nvSpPr>
         <p:spPr>
           <a:xfrm>
-            <a:off x="6446520" y="3054096"/>
-            <a:ext cx="4937760" cy="320040"/>
+            <a:off x="8412480" y="1938528"/>
+            <a:ext cx="3063240" cy="320040"/>
           </a:xfrm>
           <a:prstGeom prst="rect">
             <a:avLst/>
@@ -9982,26 +10515,26 @@
             <a:r>
               <a:rPr sz="1300" b="1">
                 <a:solidFill>
-                  <a:srgbClr val="0B5C5A"/>
-                </a:solidFill>
-                <a:latin typeface="맑은 고딕"/>
-                <a:ea typeface="맑은 고딕"/>
-              </a:rPr>
-              <a:t>요약 고치기</a:t>
-            </a:r>
-          </a:p>
-        </p:txBody>
-      </p:sp>
-      <p:sp>
-        <p:nvSpPr>
-          <p:cNvPr id="15" name="TextBox 14"/>
+                  <a:srgbClr val="E89B2E"/>
+                </a:solidFill>
+                <a:latin typeface="맑은 고딕"/>
+                <a:ea typeface="맑은 고딕"/>
+              </a:rPr>
+              <a:t>Claude가 하는 일</a:t>
+            </a:r>
+          </a:p>
+        </p:txBody>
+      </p:sp>
+      <p:sp>
+        <p:nvSpPr>
+          <p:cNvPr id="18" name="TextBox 17"/>
           <p:cNvSpPr txBox="1"/>
           <p:nvPr/>
         </p:nvSpPr>
         <p:spPr>
           <a:xfrm>
-            <a:off x="6446520" y="3401568"/>
-            <a:ext cx="4937760" cy="411480"/>
+            <a:off x="8412480" y="2331720"/>
+            <a:ext cx="3063240" cy="2194560"/>
           </a:xfrm>
           <a:prstGeom prst="rect">
             <a:avLst/>
@@ -10020,28 +10553,79 @@
               </a:spcAft>
             </a:pPr>
             <a:r>
-              <a:rPr sz="1600" b="0">
+              <a:rPr sz="1300" b="0">
                 <a:solidFill>
                   <a:srgbClr val="1F292B"/>
                 </a:solidFill>
                 <a:latin typeface="맑은 고딕"/>
                 <a:ea typeface="맑은 고딕"/>
               </a:rPr>
-              <a:t>“Limitations 부분 더 자세히 써줘”</a:t>
-            </a:r>
-          </a:p>
-        </p:txBody>
-      </p:sp>
-      <p:sp>
-        <p:nvSpPr>
-          <p:cNvPr id="16" name="Rounded Rectangle 15"/>
+              <a:t>웹 검색으로 원 발행처 자료 찾기</a:t>
+            </a:r>
+          </a:p>
+          <a:p>
+            <a:pPr algn="l">
+              <a:spcAft>
+                <a:spcPts val="600"/>
+              </a:spcAft>
+            </a:pPr>
+            <a:r>
+              <a:rPr sz="1300" b="0">
+                <a:solidFill>
+                  <a:srgbClr val="1F292B"/>
+                </a:solidFill>
+                <a:latin typeface="맑은 고딕"/>
+                <a:ea typeface="맑은 고딕"/>
+              </a:rPr>
+              <a:t>PDF·웹페이지 본문 저장</a:t>
+            </a:r>
+          </a:p>
+          <a:p>
+            <a:pPr algn="l">
+              <a:spcAft>
+                <a:spcPts val="600"/>
+              </a:spcAft>
+            </a:pPr>
+            <a:r>
+              <a:rPr sz="1300" b="0">
+                <a:solidFill>
+                  <a:srgbClr val="1F292B"/>
+                </a:solidFill>
+                <a:latin typeface="맑은 고딕"/>
+                <a:ea typeface="맑은 고딕"/>
+              </a:rPr>
+              <a:t>표지·판권면을 읽고 기관·연도·보고서 번호 채우기</a:t>
+            </a:r>
+          </a:p>
+          <a:p>
+            <a:pPr algn="l">
+              <a:spcAft>
+                <a:spcPts val="600"/>
+              </a:spcAft>
+            </a:pPr>
+            <a:r>
+              <a:rPr sz="1300" b="0">
+                <a:solidFill>
+                  <a:srgbClr val="1F292B"/>
+                </a:solidFill>
+                <a:latin typeface="맑은 고딕"/>
+                <a:ea typeface="맑은 고딕"/>
+              </a:rPr>
+              <a:t>정책 배경·과제·예산·시사점 중심 요약</a:t>
+            </a:r>
+          </a:p>
+        </p:txBody>
+      </p:sp>
+      <p:sp>
+        <p:nvSpPr>
+          <p:cNvPr id="19" name="Rounded Rectangle 18"/>
           <p:cNvSpPr/>
           <p:nvPr/>
         </p:nvSpPr>
         <p:spPr>
           <a:xfrm>
-            <a:off x="548640" y="4069080"/>
-            <a:ext cx="5440680" cy="987552"/>
+            <a:off x="8412480" y="4160520"/>
+            <a:ext cx="3017520" cy="1874519"/>
           </a:xfrm>
           <a:prstGeom prst="roundRect">
             <a:avLst>
@@ -10049,7 +10633,7 @@
             </a:avLst>
           </a:prstGeom>
           <a:solidFill>
-            <a:srgbClr val="F1F7F6"/>
+            <a:srgbClr val="FFFFFF"/>
           </a:solidFill>
           <a:ln>
             <a:noFill/>
@@ -10080,14 +10664,14 @@
       </p:sp>
       <p:sp>
         <p:nvSpPr>
-          <p:cNvPr id="17" name="TextBox 16"/>
+          <p:cNvPr id="20" name="TextBox 19"/>
           <p:cNvSpPr txBox="1"/>
           <p:nvPr/>
         </p:nvSpPr>
         <p:spPr>
           <a:xfrm>
-            <a:off x="822959" y="4197096"/>
-            <a:ext cx="4937760" cy="320040"/>
+            <a:off x="8595360" y="4297680"/>
+            <a:ext cx="2697480" cy="274320"/>
           </a:xfrm>
           <a:prstGeom prst="rect">
             <a:avLst/>
@@ -10106,28 +10690,28 @@
               </a:spcAft>
             </a:pPr>
             <a:r>
-              <a:rPr sz="1300" b="1">
+              <a:rPr sz="1100" b="1">
                 <a:solidFill>
                   <a:srgbClr val="0B5C5A"/>
                 </a:solidFill>
                 <a:latin typeface="맑은 고딕"/>
                 <a:ea typeface="맑은 고딕"/>
               </a:rPr>
-              <a:t>수치 확인</a:t>
-            </a:r>
-          </a:p>
-        </p:txBody>
-      </p:sp>
-      <p:sp>
-        <p:nvSpPr>
-          <p:cNvPr id="18" name="TextBox 17"/>
+              <a:t>인용 결과 (APA)</a:t>
+            </a:r>
+          </a:p>
+        </p:txBody>
+      </p:sp>
+      <p:sp>
+        <p:nvSpPr>
+          <p:cNvPr id="21" name="TextBox 20"/>
           <p:cNvSpPr txBox="1"/>
           <p:nvPr/>
         </p:nvSpPr>
         <p:spPr>
           <a:xfrm>
-            <a:off x="822959" y="4544568"/>
-            <a:ext cx="4937760" cy="411480"/>
+            <a:off x="8595360" y="4617720"/>
+            <a:ext cx="2697480" cy="1371600"/>
           </a:xfrm>
           <a:prstGeom prst="rect">
             <a:avLst/>
@@ -10146,392 +10730,14 @@
               </a:spcAft>
             </a:pPr>
             <a:r>
-              <a:rPr sz="1600" b="0">
+              <a:rPr sz="1200" b="0">
                 <a:solidFill>
                   <a:srgbClr val="1F292B"/>
                 </a:solidFill>
                 <a:latin typeface="맑은 고딕"/>
                 <a:ea typeface="맑은 고딕"/>
               </a:rPr>
-              <a:t>“이 수치 원문 몇 쪽인지 보여줘”</a:t>
-            </a:r>
-          </a:p>
-        </p:txBody>
-      </p:sp>
-      <p:sp>
-        <p:nvSpPr>
-          <p:cNvPr id="19" name="Rounded Rectangle 18"/>
-          <p:cNvSpPr/>
-          <p:nvPr/>
-        </p:nvSpPr>
-        <p:spPr>
-          <a:xfrm>
-            <a:off x="6172200" y="4069080"/>
-            <a:ext cx="5440680" cy="987552"/>
-          </a:xfrm>
-          <a:prstGeom prst="roundRect">
-            <a:avLst>
-              <a:gd name="adj" fmla="val 6000"/>
-            </a:avLst>
-          </a:prstGeom>
-          <a:solidFill>
-            <a:srgbClr val="F1F7F6"/>
-          </a:solidFill>
-          <a:ln>
-            <a:noFill/>
-          </a:ln>
-          <a:effectLst/>
-        </p:spPr>
-        <p:style>
-          <a:lnRef idx="1">
-            <a:schemeClr val="accent1"/>
-          </a:lnRef>
-          <a:fillRef idx="3">
-            <a:schemeClr val="accent1"/>
-          </a:fillRef>
-          <a:effectRef idx="2">
-            <a:schemeClr val="accent1"/>
-          </a:effectRef>
-          <a:fontRef idx="minor">
-            <a:schemeClr val="lt1"/>
-          </a:fontRef>
-        </p:style>
-        <p:txBody>
-          <a:bodyPr rtlCol="0" anchor="ctr"/>
-          <a:lstStyle/>
-          <a:p>
-            <a:pPr algn="ctr"/>
-          </a:p>
-        </p:txBody>
-      </p:sp>
-      <p:sp>
-        <p:nvSpPr>
-          <p:cNvPr id="20" name="TextBox 19"/>
-          <p:cNvSpPr txBox="1"/>
-          <p:nvPr/>
-        </p:nvSpPr>
-        <p:spPr>
-          <a:xfrm>
-            <a:off x="6446520" y="4197096"/>
-            <a:ext cx="4937760" cy="320040"/>
-          </a:xfrm>
-          <a:prstGeom prst="rect">
-            <a:avLst/>
-          </a:prstGeom>
-          <a:noFill/>
-        </p:spPr>
-        <p:txBody>
-          <a:bodyPr wrap="square" lIns="0" rIns="0" tIns="0" bIns="0" anchor="t">
-            <a:spAutoFit/>
-          </a:bodyPr>
-          <a:lstStyle/>
-          <a:p>
-            <a:pPr algn="l">
-              <a:spcAft>
-                <a:spcPts val="600"/>
-              </a:spcAft>
-            </a:pPr>
-            <a:r>
-              <a:rPr sz="1300" b="1">
-                <a:solidFill>
-                  <a:srgbClr val="0B5C5A"/>
-                </a:solidFill>
-                <a:latin typeface="맑은 고딕"/>
-                <a:ea typeface="맑은 고딕"/>
-              </a:rPr>
-              <a:t>출처 찾아 인용</a:t>
-            </a:r>
-          </a:p>
-        </p:txBody>
-      </p:sp>
-      <p:sp>
-        <p:nvSpPr>
-          <p:cNvPr id="21" name="TextBox 20"/>
-          <p:cNvSpPr txBox="1"/>
-          <p:nvPr/>
-        </p:nvSpPr>
-        <p:spPr>
-          <a:xfrm>
-            <a:off x="6446520" y="4544568"/>
-            <a:ext cx="4937760" cy="411480"/>
-          </a:xfrm>
-          <a:prstGeom prst="rect">
-            <a:avLst/>
-          </a:prstGeom>
-          <a:noFill/>
-        </p:spPr>
-        <p:txBody>
-          <a:bodyPr wrap="square" lIns="0" rIns="0" tIns="0" bIns="0" anchor="t">
-            <a:spAutoFit/>
-          </a:bodyPr>
-          <a:lstStyle/>
-          <a:p>
-            <a:pPr algn="l">
-              <a:spcAft>
-                <a:spcPts val="600"/>
-              </a:spcAft>
-            </a:pPr>
-            <a:r>
-              <a:rPr sz="1600" b="0">
-                <a:solidFill>
-                  <a:srgbClr val="1F292B"/>
-                </a:solidFill>
-                <a:latin typeface="맑은 고딕"/>
-                <a:ea typeface="맑은 고딕"/>
-              </a:rPr>
-              <a:t>“이 문장에 맞는 출처 찾아서 인용 달아줘”</a:t>
-            </a:r>
-          </a:p>
-        </p:txBody>
-      </p:sp>
-      <p:sp>
-        <p:nvSpPr>
-          <p:cNvPr id="22" name="Rounded Rectangle 21"/>
-          <p:cNvSpPr/>
-          <p:nvPr/>
-        </p:nvSpPr>
-        <p:spPr>
-          <a:xfrm>
-            <a:off x="548640" y="5212080"/>
-            <a:ext cx="5440680" cy="987552"/>
-          </a:xfrm>
-          <a:prstGeom prst="roundRect">
-            <a:avLst>
-              <a:gd name="adj" fmla="val 6000"/>
-            </a:avLst>
-          </a:prstGeom>
-          <a:solidFill>
-            <a:srgbClr val="F1F7F6"/>
-          </a:solidFill>
-          <a:ln>
-            <a:noFill/>
-          </a:ln>
-          <a:effectLst/>
-        </p:spPr>
-        <p:style>
-          <a:lnRef idx="1">
-            <a:schemeClr val="accent1"/>
-          </a:lnRef>
-          <a:fillRef idx="3">
-            <a:schemeClr val="accent1"/>
-          </a:fillRef>
-          <a:effectRef idx="2">
-            <a:schemeClr val="accent1"/>
-          </a:effectRef>
-          <a:fontRef idx="minor">
-            <a:schemeClr val="lt1"/>
-          </a:fontRef>
-        </p:style>
-        <p:txBody>
-          <a:bodyPr rtlCol="0" anchor="ctr"/>
-          <a:lstStyle/>
-          <a:p>
-            <a:pPr algn="ctr"/>
-          </a:p>
-        </p:txBody>
-      </p:sp>
-      <p:sp>
-        <p:nvSpPr>
-          <p:cNvPr id="23" name="TextBox 22"/>
-          <p:cNvSpPr txBox="1"/>
-          <p:nvPr/>
-        </p:nvSpPr>
-        <p:spPr>
-          <a:xfrm>
-            <a:off x="822959" y="5340096"/>
-            <a:ext cx="4937760" cy="320040"/>
-          </a:xfrm>
-          <a:prstGeom prst="rect">
-            <a:avLst/>
-          </a:prstGeom>
-          <a:noFill/>
-        </p:spPr>
-        <p:txBody>
-          <a:bodyPr wrap="square" lIns="0" rIns="0" tIns="0" bIns="0" anchor="t">
-            <a:spAutoFit/>
-          </a:bodyPr>
-          <a:lstStyle/>
-          <a:p>
-            <a:pPr algn="l">
-              <a:spcAft>
-                <a:spcPts val="600"/>
-              </a:spcAft>
-            </a:pPr>
-            <a:r>
-              <a:rPr sz="1300" b="1">
-                <a:solidFill>
-                  <a:srgbClr val="0B5C5A"/>
-                </a:solidFill>
-                <a:latin typeface="맑은 고딕"/>
-                <a:ea typeface="맑은 고딕"/>
-              </a:rPr>
-              <a:t>PDF 대기 목록</a:t>
-            </a:r>
-          </a:p>
-        </p:txBody>
-      </p:sp>
-      <p:sp>
-        <p:nvSpPr>
-          <p:cNvPr id="24" name="TextBox 23"/>
-          <p:cNvSpPr txBox="1"/>
-          <p:nvPr/>
-        </p:nvSpPr>
-        <p:spPr>
-          <a:xfrm>
-            <a:off x="822959" y="5687568"/>
-            <a:ext cx="4937760" cy="411480"/>
-          </a:xfrm>
-          <a:prstGeom prst="rect">
-            <a:avLst/>
-          </a:prstGeom>
-          <a:noFill/>
-        </p:spPr>
-        <p:txBody>
-          <a:bodyPr wrap="square" lIns="0" rIns="0" tIns="0" bIns="0" anchor="t">
-            <a:spAutoFit/>
-          </a:bodyPr>
-          <a:lstStyle/>
-          <a:p>
-            <a:pPr algn="l">
-              <a:spcAft>
-                <a:spcPts val="600"/>
-              </a:spcAft>
-            </a:pPr>
-            <a:r>
-              <a:rPr sz="1600" b="0">
-                <a:solidFill>
-                  <a:srgbClr val="1F292B"/>
-                </a:solidFill>
-                <a:latin typeface="맑은 고딕"/>
-                <a:ea typeface="맑은 고딕"/>
-              </a:rPr>
-              <a:t>“PDF 기다리는 논문 목록 보여줘”</a:t>
-            </a:r>
-          </a:p>
-        </p:txBody>
-      </p:sp>
-      <p:sp>
-        <p:nvSpPr>
-          <p:cNvPr id="25" name="Rounded Rectangle 24"/>
-          <p:cNvSpPr/>
-          <p:nvPr/>
-        </p:nvSpPr>
-        <p:spPr>
-          <a:xfrm>
-            <a:off x="6172200" y="5212080"/>
-            <a:ext cx="5440680" cy="987552"/>
-          </a:xfrm>
-          <a:prstGeom prst="roundRect">
-            <a:avLst>
-              <a:gd name="adj" fmla="val 6000"/>
-            </a:avLst>
-          </a:prstGeom>
-          <a:solidFill>
-            <a:srgbClr val="F1F7F6"/>
-          </a:solidFill>
-          <a:ln>
-            <a:noFill/>
-          </a:ln>
-          <a:effectLst/>
-        </p:spPr>
-        <p:style>
-          <a:lnRef idx="1">
-            <a:schemeClr val="accent1"/>
-          </a:lnRef>
-          <a:fillRef idx="3">
-            <a:schemeClr val="accent1"/>
-          </a:fillRef>
-          <a:effectRef idx="2">
-            <a:schemeClr val="accent1"/>
-          </a:effectRef>
-          <a:fontRef idx="minor">
-            <a:schemeClr val="lt1"/>
-          </a:fontRef>
-        </p:style>
-        <p:txBody>
-          <a:bodyPr rtlCol="0" anchor="ctr"/>
-          <a:lstStyle/>
-          <a:p>
-            <a:pPr algn="ctr"/>
-          </a:p>
-        </p:txBody>
-      </p:sp>
-      <p:sp>
-        <p:nvSpPr>
-          <p:cNvPr id="26" name="TextBox 25"/>
-          <p:cNvSpPr txBox="1"/>
-          <p:nvPr/>
-        </p:nvSpPr>
-        <p:spPr>
-          <a:xfrm>
-            <a:off x="6446520" y="5340096"/>
-            <a:ext cx="4937760" cy="320040"/>
-          </a:xfrm>
-          <a:prstGeom prst="rect">
-            <a:avLst/>
-          </a:prstGeom>
-          <a:noFill/>
-        </p:spPr>
-        <p:txBody>
-          <a:bodyPr wrap="square" lIns="0" rIns="0" tIns="0" bIns="0" anchor="t">
-            <a:spAutoFit/>
-          </a:bodyPr>
-          <a:lstStyle/>
-          <a:p>
-            <a:pPr algn="l">
-              <a:spcAft>
-                <a:spcPts val="600"/>
-              </a:spcAft>
-            </a:pPr>
-            <a:r>
-              <a:rPr sz="1300" b="1">
-                <a:solidFill>
-                  <a:srgbClr val="0B5C5A"/>
-                </a:solidFill>
-                <a:latin typeface="맑은 고딕"/>
-                <a:ea typeface="맑은 고딕"/>
-              </a:rPr>
-              <a:t>스킬 업데이트</a:t>
-            </a:r>
-          </a:p>
-        </p:txBody>
-      </p:sp>
-      <p:sp>
-        <p:nvSpPr>
-          <p:cNvPr id="27" name="TextBox 26"/>
-          <p:cNvSpPr txBox="1"/>
-          <p:nvPr/>
-        </p:nvSpPr>
-        <p:spPr>
-          <a:xfrm>
-            <a:off x="6446520" y="5687568"/>
-            <a:ext cx="4937760" cy="411480"/>
-          </a:xfrm>
-          <a:prstGeom prst="rect">
-            <a:avLst/>
-          </a:prstGeom>
-          <a:noFill/>
-        </p:spPr>
-        <p:txBody>
-          <a:bodyPr wrap="square" lIns="0" rIns="0" tIns="0" bIns="0" anchor="t">
-            <a:spAutoFit/>
-          </a:bodyPr>
-          <a:lstStyle/>
-          <a:p>
-            <a:pPr algn="l">
-              <a:spcAft>
-                <a:spcPts val="600"/>
-              </a:spcAft>
-            </a:pPr>
-            <a:r>
-              <a:rPr sz="1600" b="0">
-                <a:solidFill>
-                  <a:srgbClr val="1F292B"/>
-                </a:solidFill>
-                <a:latin typeface="맑은 고딕"/>
-                <a:ea typeface="맑은 고딕"/>
-              </a:rPr>
-              <a:t>“paper-summary 최신 버전으로 업데이트해줘”</a:t>
+              <a:t>과학기술정책연구원. (2025). 인공지능 시대의 과학기술 인재정책 방향 (정책연구 2025-07).</a:t>
             </a:r>
           </a:p>
         </p:txBody>
@@ -10597,7 +10803,7 @@
                 <a:latin typeface="맑은 고딕"/>
                 <a:ea typeface="맑은 고딕"/>
               </a:rPr>
-              <a:t>라이브러리 구조와 자주 묻는 질문</a:t>
+              <a:t>이럴 땐 이렇게 말하세요</a:t>
             </a:r>
           </a:p>
         </p:txBody>
@@ -10637,7 +10843,7 @@
                 <a:latin typeface="맑은 고딕"/>
                 <a:ea typeface="맑은 고딕"/>
               </a:rPr>
-              <a:t>기본 위치 ~/paper-library (환경 변수 PAPER_LIB로 변경)</a:t>
+              <a:t>명령어를 외울 필요 없이 — Claude가 알아서 실행합니다</a:t>
             </a:r>
           </a:p>
         </p:txBody>
@@ -10651,235 +10857,7 @@
         <p:spPr>
           <a:xfrm>
             <a:off x="548640" y="1783080"/>
-            <a:ext cx="5212080" cy="2651760"/>
-          </a:xfrm>
-          <a:prstGeom prst="roundRect">
-            <a:avLst>
-              <a:gd name="adj" fmla="val 4000"/>
-            </a:avLst>
-          </a:prstGeom>
-          <a:solidFill>
-            <a:srgbClr val="1B2628"/>
-          </a:solidFill>
-          <a:ln>
-            <a:noFill/>
-          </a:ln>
-          <a:effectLst/>
-        </p:spPr>
-        <p:style>
-          <a:lnRef idx="1">
-            <a:schemeClr val="accent1"/>
-          </a:lnRef>
-          <a:fillRef idx="3">
-            <a:schemeClr val="accent1"/>
-          </a:fillRef>
-          <a:effectRef idx="2">
-            <a:schemeClr val="accent1"/>
-          </a:effectRef>
-          <a:fontRef idx="minor">
-            <a:schemeClr val="lt1"/>
-          </a:fontRef>
-        </p:style>
-        <p:txBody>
-          <a:bodyPr rtlCol="0" anchor="ctr"/>
-          <a:lstStyle/>
-          <a:p>
-            <a:pPr algn="ctr"/>
-          </a:p>
-        </p:txBody>
-      </p:sp>
-      <p:sp>
-        <p:nvSpPr>
-          <p:cNvPr id="5" name="TextBox 4"/>
-          <p:cNvSpPr txBox="1"/>
-          <p:nvPr/>
-        </p:nvSpPr>
-        <p:spPr>
-          <a:xfrm>
-            <a:off x="777240" y="1947672"/>
-            <a:ext cx="4754880" cy="274320"/>
-          </a:xfrm>
-          <a:prstGeom prst="rect">
-            <a:avLst/>
-          </a:prstGeom>
-          <a:noFill/>
-        </p:spPr>
-        <p:txBody>
-          <a:bodyPr wrap="square" lIns="0" rIns="0" tIns="0" bIns="0" anchor="t">
-            <a:spAutoFit/>
-          </a:bodyPr>
-          <a:lstStyle/>
-          <a:p>
-            <a:pPr algn="l">
-              <a:spcAft>
-                <a:spcPts val="600"/>
-              </a:spcAft>
-            </a:pPr>
-            <a:r>
-              <a:rPr sz="1100" b="1">
-                <a:solidFill>
-                  <a:srgbClr val="8FD3C8"/>
-                </a:solidFill>
-                <a:latin typeface="맑은 고딕"/>
-                <a:ea typeface="맑은 고딕"/>
-              </a:rPr>
-              <a:t>폴더 구조</a:t>
-            </a:r>
-          </a:p>
-        </p:txBody>
-      </p:sp>
-      <p:sp>
-        <p:nvSpPr>
-          <p:cNvPr id="6" name="TextBox 5"/>
-          <p:cNvSpPr txBox="1"/>
-          <p:nvPr/>
-        </p:nvSpPr>
-        <p:spPr>
-          <a:xfrm>
-            <a:off x="777240" y="2240279"/>
-            <a:ext cx="4754880" cy="2377440"/>
-          </a:xfrm>
-          <a:prstGeom prst="rect">
-            <a:avLst/>
-          </a:prstGeom>
-          <a:noFill/>
-        </p:spPr>
-        <p:txBody>
-          <a:bodyPr wrap="square" lIns="0" rIns="0" tIns="0" bIns="0" anchor="t">
-            <a:spAutoFit/>
-          </a:bodyPr>
-          <a:lstStyle/>
-          <a:p>
-            <a:pPr algn="l">
-              <a:spcAft>
-                <a:spcPts val="200"/>
-              </a:spcAft>
-            </a:pPr>
-            <a:r>
-              <a:rPr sz="1300" b="0">
-                <a:solidFill>
-                  <a:srgbClr val="E6EDEE"/>
-                </a:solidFill>
-                <a:latin typeface="Consolas"/>
-                <a:ea typeface="맑은 고딕"/>
-              </a:rPr>
-              <a:t>paper-library/</a:t>
-            </a:r>
-          </a:p>
-          <a:p>
-            <a:pPr algn="l">
-              <a:spcAft>
-                <a:spcPts val="200"/>
-              </a:spcAft>
-            </a:pPr>
-            <a:r>
-              <a:rPr sz="1300" b="0">
-                <a:solidFill>
-                  <a:srgbClr val="E6EDEE"/>
-                </a:solidFill>
-                <a:latin typeface="Consolas"/>
-                <a:ea typeface="맑은 고딕"/>
-              </a:rPr>
-              <a:t>  index.html   library.json</a:t>
-            </a:r>
-          </a:p>
-          <a:p>
-            <a:pPr algn="l">
-              <a:spcAft>
-                <a:spcPts val="200"/>
-              </a:spcAft>
-            </a:pPr>
-            <a:r>
-              <a:rPr sz="1300" b="0">
-                <a:solidFill>
-                  <a:srgbClr val="E6EDEE"/>
-                </a:solidFill>
-                <a:latin typeface="Consolas"/>
-                <a:ea typeface="맑은 고딕"/>
-              </a:rPr>
-              <a:t>  library.bib</a:t>
-            </a:r>
-          </a:p>
-          <a:p>
-            <a:pPr algn="l">
-              <a:spcAft>
-                <a:spcPts val="200"/>
-              </a:spcAft>
-            </a:pPr>
-            <a:r>
-              <a:rPr sz="1300" b="0">
-                <a:solidFill>
-                  <a:srgbClr val="E6EDEE"/>
-                </a:solidFill>
-                <a:latin typeface="Consolas"/>
-                <a:ea typeface="맑은 고딕"/>
-              </a:rPr>
-              <a:t>  papers/Pstras2026estimating/</a:t>
-            </a:r>
-          </a:p>
-          <a:p>
-            <a:pPr algn="l">
-              <a:spcAft>
-                <a:spcPts val="200"/>
-              </a:spcAft>
-            </a:pPr>
-            <a:r>
-              <a:rPr sz="1300" b="0">
-                <a:solidFill>
-                  <a:srgbClr val="E6EDEE"/>
-                </a:solidFill>
-                <a:latin typeface="Consolas"/>
-                <a:ea typeface="맑은 고딕"/>
-              </a:rPr>
-              <a:t>    meta.json    paper.pdf</a:t>
-            </a:r>
-          </a:p>
-          <a:p>
-            <a:pPr algn="l">
-              <a:spcAft>
-                <a:spcPts val="200"/>
-              </a:spcAft>
-            </a:pPr>
-            <a:r>
-              <a:rPr sz="1300" b="0">
-                <a:solidFill>
-                  <a:srgbClr val="E6EDEE"/>
-                </a:solidFill>
-                <a:latin typeface="Consolas"/>
-                <a:ea typeface="맑은 고딕"/>
-              </a:rPr>
-              <a:t>    text.md      figures/</a:t>
-            </a:r>
-          </a:p>
-          <a:p>
-            <a:pPr algn="l">
-              <a:spcAft>
-                <a:spcPts val="200"/>
-              </a:spcAft>
-            </a:pPr>
-            <a:r>
-              <a:rPr sz="1300" b="0">
-                <a:solidFill>
-                  <a:srgbClr val="E6EDEE"/>
-                </a:solidFill>
-                <a:latin typeface="Consolas"/>
-                <a:ea typeface="맑은 고딕"/>
-              </a:rPr>
-              <a:t>    summary.md   index.html</a:t>
-            </a:r>
-          </a:p>
-        </p:txBody>
-      </p:sp>
-      <p:sp>
-        <p:nvSpPr>
-          <p:cNvPr id="7" name="Rounded Rectangle 6"/>
-          <p:cNvSpPr/>
-          <p:nvPr/>
-        </p:nvSpPr>
-        <p:spPr>
-          <a:xfrm>
-            <a:off x="6035040" y="1783080"/>
-            <a:ext cx="5623560" cy="987552"/>
+            <a:ext cx="5440680" cy="987552"/>
           </a:xfrm>
           <a:prstGeom prst="roundRect">
             <a:avLst>
@@ -10918,14 +10896,14 @@
       </p:sp>
       <p:sp>
         <p:nvSpPr>
-          <p:cNvPr id="8" name="TextBox 7"/>
+          <p:cNvPr id="5" name="TextBox 4"/>
           <p:cNvSpPr txBox="1"/>
           <p:nvPr/>
         </p:nvSpPr>
         <p:spPr>
           <a:xfrm>
-            <a:off x="6263640" y="1901952"/>
-            <a:ext cx="5212080" cy="365760"/>
+            <a:off x="822959" y="1911095"/>
+            <a:ext cx="4937760" cy="320040"/>
           </a:xfrm>
           <a:prstGeom prst="rect">
             <a:avLst/>
@@ -10944,28 +10922,28 @@
               </a:spcAft>
             </a:pPr>
             <a:r>
-              <a:rPr sz="1500" b="1">
-                <a:solidFill>
-                  <a:srgbClr val="0E2F2E"/>
-                </a:solidFill>
-                <a:latin typeface="맑은 고딕"/>
-                <a:ea typeface="맑은 고딕"/>
-              </a:rPr>
-              <a:t>Q. API 비용이 드나요?</a:t>
-            </a:r>
-          </a:p>
-        </p:txBody>
-      </p:sp>
-      <p:sp>
-        <p:nvSpPr>
-          <p:cNvPr id="9" name="TextBox 8"/>
+              <a:rPr sz="1300" b="1">
+                <a:solidFill>
+                  <a:srgbClr val="0B5C5A"/>
+                </a:solidFill>
+                <a:latin typeface="맑은 고딕"/>
+                <a:ea typeface="맑은 고딕"/>
+              </a:rPr>
+              <a:t>가진 PDF 정리</a:t>
+            </a:r>
+          </a:p>
+        </p:txBody>
+      </p:sp>
+      <p:sp>
+        <p:nvSpPr>
+          <p:cNvPr id="6" name="TextBox 5"/>
           <p:cNvSpPr txBox="1"/>
           <p:nvPr/>
         </p:nvSpPr>
         <p:spPr>
           <a:xfrm>
-            <a:off x="6263640" y="2267712"/>
-            <a:ext cx="5212080" cy="457200"/>
+            <a:off x="822959" y="2258568"/>
+            <a:ext cx="4937760" cy="411480"/>
           </a:xfrm>
           <a:prstGeom prst="rect">
             <a:avLst/>
@@ -10984,28 +10962,28 @@
               </a:spcAft>
             </a:pPr>
             <a:r>
-              <a:rPr sz="1300" b="0">
+              <a:rPr sz="1600" b="0">
                 <a:solidFill>
                   <a:srgbClr val="1F292B"/>
                 </a:solidFill>
                 <a:latin typeface="맑은 고딕"/>
                 <a:ea typeface="맑은 고딕"/>
               </a:rPr>
-              <a:t>아니요. 무료 공개 API만 쓰고 요약은 대화 안에서 합니다.</a:t>
-            </a:r>
-          </a:p>
-        </p:txBody>
-      </p:sp>
-      <p:sp>
-        <p:nvSpPr>
-          <p:cNvPr id="10" name="Rounded Rectangle 9"/>
+              <a:t>“Downloads 폴더의 paper.pdf 논문 요약해줘”</a:t>
+            </a:r>
+          </a:p>
+        </p:txBody>
+      </p:sp>
+      <p:sp>
+        <p:nvSpPr>
+          <p:cNvPr id="7" name="Rounded Rectangle 6"/>
           <p:cNvSpPr/>
           <p:nvPr/>
         </p:nvSpPr>
         <p:spPr>
           <a:xfrm>
-            <a:off x="6035040" y="2898648"/>
-            <a:ext cx="5623560" cy="987552"/>
+            <a:off x="6172200" y="1783080"/>
+            <a:ext cx="5440680" cy="987552"/>
           </a:xfrm>
           <a:prstGeom prst="roundRect">
             <a:avLst>
@@ -11044,14 +11022,14 @@
       </p:sp>
       <p:sp>
         <p:nvSpPr>
-          <p:cNvPr id="11" name="TextBox 10"/>
+          <p:cNvPr id="8" name="TextBox 7"/>
           <p:cNvSpPr txBox="1"/>
           <p:nvPr/>
         </p:nvSpPr>
         <p:spPr>
           <a:xfrm>
-            <a:off x="6263640" y="3017520"/>
-            <a:ext cx="5212080" cy="365760"/>
+            <a:off x="6446520" y="1911095"/>
+            <a:ext cx="4937760" cy="320040"/>
           </a:xfrm>
           <a:prstGeom prst="rect">
             <a:avLst/>
@@ -11070,28 +11048,28 @@
               </a:spcAft>
             </a:pPr>
             <a:r>
-              <a:rPr sz="1500" b="1">
-                <a:solidFill>
-                  <a:srgbClr val="0E2F2E"/>
-                </a:solidFill>
-                <a:latin typeface="맑은 고딕"/>
-                <a:ea typeface="맑은 고딕"/>
-              </a:rPr>
-              <a:t>Q. 그림이 잘못 잘렸어요</a:t>
-            </a:r>
-          </a:p>
-        </p:txBody>
-      </p:sp>
-      <p:sp>
-        <p:nvSpPr>
-          <p:cNvPr id="12" name="TextBox 11"/>
+              <a:rPr sz="1300" b="1">
+                <a:solidFill>
+                  <a:srgbClr val="0B5C5A"/>
+                </a:solidFill>
+                <a:latin typeface="맑은 고딕"/>
+                <a:ea typeface="맑은 고딕"/>
+              </a:rPr>
+              <a:t>저장한 논문 찾기</a:t>
+            </a:r>
+          </a:p>
+        </p:txBody>
+      </p:sp>
+      <p:sp>
+        <p:nvSpPr>
+          <p:cNvPr id="9" name="TextBox 8"/>
           <p:cNvSpPr txBox="1"/>
           <p:nvPr/>
         </p:nvSpPr>
         <p:spPr>
           <a:xfrm>
-            <a:off x="6263640" y="3383280"/>
-            <a:ext cx="5212080" cy="457200"/>
+            <a:off x="6446520" y="2258568"/>
+            <a:ext cx="4937760" cy="411480"/>
           </a:xfrm>
           <a:prstGeom prst="rect">
             <a:avLst/>
@@ -11110,28 +11088,28 @@
               </a:spcAft>
             </a:pPr>
             <a:r>
-              <a:rPr sz="1300" b="0">
+              <a:rPr sz="1600" b="0">
                 <a:solidFill>
                   <a:srgbClr val="1F292B"/>
                 </a:solidFill>
                 <a:latin typeface="맑은 고딕"/>
                 <a:ea typeface="맑은 고딕"/>
               </a:rPr>
-              <a:t>캡션 기준이라 특이한 PDF는 놓칠 수 있고, 요약 때 걸러냄</a:t>
-            </a:r>
-          </a:p>
-        </p:txBody>
-      </p:sp>
-      <p:sp>
-        <p:nvSpPr>
-          <p:cNvPr id="13" name="Rounded Rectangle 12"/>
+              <a:t>“라이브러리에서 SDNN 언급한 논문 찾아줘”</a:t>
+            </a:r>
+          </a:p>
+        </p:txBody>
+      </p:sp>
+      <p:sp>
+        <p:nvSpPr>
+          <p:cNvPr id="10" name="Rounded Rectangle 9"/>
           <p:cNvSpPr/>
           <p:nvPr/>
         </p:nvSpPr>
         <p:spPr>
           <a:xfrm>
-            <a:off x="6035040" y="4014215"/>
-            <a:ext cx="5623560" cy="987552"/>
+            <a:off x="548640" y="2926080"/>
+            <a:ext cx="5440680" cy="987552"/>
           </a:xfrm>
           <a:prstGeom prst="roundRect">
             <a:avLst>
@@ -11170,14 +11148,14 @@
       </p:sp>
       <p:sp>
         <p:nvSpPr>
-          <p:cNvPr id="14" name="TextBox 13"/>
+          <p:cNvPr id="11" name="TextBox 10"/>
           <p:cNvSpPr txBox="1"/>
           <p:nvPr/>
         </p:nvSpPr>
         <p:spPr>
           <a:xfrm>
-            <a:off x="6263640" y="4133087"/>
-            <a:ext cx="5212080" cy="365760"/>
+            <a:off x="822959" y="3054096"/>
+            <a:ext cx="4937760" cy="320040"/>
           </a:xfrm>
           <a:prstGeom prst="rect">
             <a:avLst/>
@@ -11196,28 +11174,28 @@
               </a:spcAft>
             </a:pPr>
             <a:r>
-              <a:rPr sz="1500" b="1">
-                <a:solidFill>
-                  <a:srgbClr val="0E2F2E"/>
-                </a:solidFill>
-                <a:latin typeface="맑은 고딕"/>
-                <a:ea typeface="맑은 고딕"/>
-              </a:rPr>
-              <a:t>Q. 다른 PC로 옮기려면?</a:t>
-            </a:r>
-          </a:p>
-        </p:txBody>
-      </p:sp>
-      <p:sp>
-        <p:nvSpPr>
-          <p:cNvPr id="15" name="TextBox 14"/>
+              <a:rPr sz="1300" b="1">
+                <a:solidFill>
+                  <a:srgbClr val="0B5C5A"/>
+                </a:solidFill>
+                <a:latin typeface="맑은 고딕"/>
+                <a:ea typeface="맑은 고딕"/>
+              </a:rPr>
+              <a:t>요약 다시 보기</a:t>
+            </a:r>
+          </a:p>
+        </p:txBody>
+      </p:sp>
+      <p:sp>
+        <p:nvSpPr>
+          <p:cNvPr id="12" name="TextBox 11"/>
           <p:cNvSpPr txBox="1"/>
           <p:nvPr/>
         </p:nvSpPr>
         <p:spPr>
           <a:xfrm>
-            <a:off x="6263640" y="4498848"/>
-            <a:ext cx="5212080" cy="457200"/>
+            <a:off x="822959" y="3401568"/>
+            <a:ext cx="4937760" cy="411480"/>
           </a:xfrm>
           <a:prstGeom prst="rect">
             <a:avLst/>
@@ -11236,28 +11214,28 @@
               </a:spcAft>
             </a:pPr>
             <a:r>
-              <a:rPr sz="1300" b="0">
+              <a:rPr sz="1600" b="0">
                 <a:solidFill>
                   <a:srgbClr val="1F292B"/>
                 </a:solidFill>
                 <a:latin typeface="맑은 고딕"/>
                 <a:ea typeface="맑은 고딕"/>
               </a:rPr>
-              <a:t>paper-library 폴더를 통째로 복사. 공개 저장소엔 올리지 마세요.</a:t>
-            </a:r>
-          </a:p>
-        </p:txBody>
-      </p:sp>
-      <p:sp>
-        <p:nvSpPr>
-          <p:cNvPr id="16" name="Rounded Rectangle 15"/>
+              <a:t>“Sampath2026adaptive 요약 HTML로 열어줘”</a:t>
+            </a:r>
+          </a:p>
+        </p:txBody>
+      </p:sp>
+      <p:sp>
+        <p:nvSpPr>
+          <p:cNvPr id="13" name="Rounded Rectangle 12"/>
           <p:cNvSpPr/>
           <p:nvPr/>
         </p:nvSpPr>
         <p:spPr>
           <a:xfrm>
-            <a:off x="6035040" y="5129784"/>
-            <a:ext cx="5623560" cy="987552"/>
+            <a:off x="6172200" y="2926080"/>
+            <a:ext cx="5440680" cy="987552"/>
           </a:xfrm>
           <a:prstGeom prst="roundRect">
             <a:avLst>
@@ -11296,14 +11274,14 @@
       </p:sp>
       <p:sp>
         <p:nvSpPr>
-          <p:cNvPr id="17" name="TextBox 16"/>
+          <p:cNvPr id="14" name="TextBox 13"/>
           <p:cNvSpPr txBox="1"/>
           <p:nvPr/>
         </p:nvSpPr>
         <p:spPr>
           <a:xfrm>
-            <a:off x="6263640" y="5248656"/>
-            <a:ext cx="5212080" cy="365760"/>
+            <a:off x="6446520" y="3054096"/>
+            <a:ext cx="4937760" cy="320040"/>
           </a:xfrm>
           <a:prstGeom prst="rect">
             <a:avLst/>
@@ -11322,28 +11300,28 @@
               </a:spcAft>
             </a:pPr>
             <a:r>
-              <a:rPr sz="1500" b="1">
-                <a:solidFill>
-                  <a:srgbClr val="0E2F2E"/>
-                </a:solidFill>
-                <a:latin typeface="맑은 고딕"/>
-                <a:ea typeface="맑은 고딕"/>
-              </a:rPr>
-              <a:t>Q. 최신 버전 받기</a:t>
-            </a:r>
-          </a:p>
-        </p:txBody>
-      </p:sp>
-      <p:sp>
-        <p:nvSpPr>
-          <p:cNvPr id="18" name="TextBox 17"/>
+              <a:rPr sz="1300" b="1">
+                <a:solidFill>
+                  <a:srgbClr val="0B5C5A"/>
+                </a:solidFill>
+                <a:latin typeface="맑은 고딕"/>
+                <a:ea typeface="맑은 고딕"/>
+              </a:rPr>
+              <a:t>요약 고치기</a:t>
+            </a:r>
+          </a:p>
+        </p:txBody>
+      </p:sp>
+      <p:sp>
+        <p:nvSpPr>
+          <p:cNvPr id="15" name="TextBox 14"/>
           <p:cNvSpPr txBox="1"/>
           <p:nvPr/>
         </p:nvSpPr>
         <p:spPr>
           <a:xfrm>
-            <a:off x="6263640" y="5614416"/>
-            <a:ext cx="5212080" cy="457200"/>
+            <a:off x="6446520" y="3401568"/>
+            <a:ext cx="4937760" cy="411480"/>
           </a:xfrm>
           <a:prstGeom prst="rect">
             <a:avLst/>
@@ -11362,14 +11340,518 @@
               </a:spcAft>
             </a:pPr>
             <a:r>
-              <a:rPr sz="1300" b="0">
+              <a:rPr sz="1600" b="0">
                 <a:solidFill>
                   <a:srgbClr val="1F292B"/>
                 </a:solidFill>
                 <a:latin typeface="맑은 고딕"/>
                 <a:ea typeface="맑은 고딕"/>
               </a:rPr>
-              <a:t>“paper-summary 스킬 최신 버전으로 업데이트해줘”</a:t>
+              <a:t>“Limitations 부분 더 자세히 써줘”</a:t>
+            </a:r>
+          </a:p>
+        </p:txBody>
+      </p:sp>
+      <p:sp>
+        <p:nvSpPr>
+          <p:cNvPr id="16" name="Rounded Rectangle 15"/>
+          <p:cNvSpPr/>
+          <p:nvPr/>
+        </p:nvSpPr>
+        <p:spPr>
+          <a:xfrm>
+            <a:off x="548640" y="4069080"/>
+            <a:ext cx="5440680" cy="987552"/>
+          </a:xfrm>
+          <a:prstGeom prst="roundRect">
+            <a:avLst>
+              <a:gd name="adj" fmla="val 6000"/>
+            </a:avLst>
+          </a:prstGeom>
+          <a:solidFill>
+            <a:srgbClr val="F1F7F6"/>
+          </a:solidFill>
+          <a:ln>
+            <a:noFill/>
+          </a:ln>
+          <a:effectLst/>
+        </p:spPr>
+        <p:style>
+          <a:lnRef idx="1">
+            <a:schemeClr val="accent1"/>
+          </a:lnRef>
+          <a:fillRef idx="3">
+            <a:schemeClr val="accent1"/>
+          </a:fillRef>
+          <a:effectRef idx="2">
+            <a:schemeClr val="accent1"/>
+          </a:effectRef>
+          <a:fontRef idx="minor">
+            <a:schemeClr val="lt1"/>
+          </a:fontRef>
+        </p:style>
+        <p:txBody>
+          <a:bodyPr rtlCol="0" anchor="ctr"/>
+          <a:lstStyle/>
+          <a:p>
+            <a:pPr algn="ctr"/>
+          </a:p>
+        </p:txBody>
+      </p:sp>
+      <p:sp>
+        <p:nvSpPr>
+          <p:cNvPr id="17" name="TextBox 16"/>
+          <p:cNvSpPr txBox="1"/>
+          <p:nvPr/>
+        </p:nvSpPr>
+        <p:spPr>
+          <a:xfrm>
+            <a:off x="822959" y="4197096"/>
+            <a:ext cx="4937760" cy="320040"/>
+          </a:xfrm>
+          <a:prstGeom prst="rect">
+            <a:avLst/>
+          </a:prstGeom>
+          <a:noFill/>
+        </p:spPr>
+        <p:txBody>
+          <a:bodyPr wrap="square" lIns="0" rIns="0" tIns="0" bIns="0" anchor="t">
+            <a:spAutoFit/>
+          </a:bodyPr>
+          <a:lstStyle/>
+          <a:p>
+            <a:pPr algn="l">
+              <a:spcAft>
+                <a:spcPts val="600"/>
+              </a:spcAft>
+            </a:pPr>
+            <a:r>
+              <a:rPr sz="1300" b="1">
+                <a:solidFill>
+                  <a:srgbClr val="0B5C5A"/>
+                </a:solidFill>
+                <a:latin typeface="맑은 고딕"/>
+                <a:ea typeface="맑은 고딕"/>
+              </a:rPr>
+              <a:t>수치 확인</a:t>
+            </a:r>
+          </a:p>
+        </p:txBody>
+      </p:sp>
+      <p:sp>
+        <p:nvSpPr>
+          <p:cNvPr id="18" name="TextBox 17"/>
+          <p:cNvSpPr txBox="1"/>
+          <p:nvPr/>
+        </p:nvSpPr>
+        <p:spPr>
+          <a:xfrm>
+            <a:off x="822959" y="4544568"/>
+            <a:ext cx="4937760" cy="411480"/>
+          </a:xfrm>
+          <a:prstGeom prst="rect">
+            <a:avLst/>
+          </a:prstGeom>
+          <a:noFill/>
+        </p:spPr>
+        <p:txBody>
+          <a:bodyPr wrap="square" lIns="0" rIns="0" tIns="0" bIns="0" anchor="t">
+            <a:spAutoFit/>
+          </a:bodyPr>
+          <a:lstStyle/>
+          <a:p>
+            <a:pPr algn="l">
+              <a:spcAft>
+                <a:spcPts val="600"/>
+              </a:spcAft>
+            </a:pPr>
+            <a:r>
+              <a:rPr sz="1600" b="0">
+                <a:solidFill>
+                  <a:srgbClr val="1F292B"/>
+                </a:solidFill>
+                <a:latin typeface="맑은 고딕"/>
+                <a:ea typeface="맑은 고딕"/>
+              </a:rPr>
+              <a:t>“이 수치 원문 몇 쪽인지 보여줘”</a:t>
+            </a:r>
+          </a:p>
+        </p:txBody>
+      </p:sp>
+      <p:sp>
+        <p:nvSpPr>
+          <p:cNvPr id="19" name="Rounded Rectangle 18"/>
+          <p:cNvSpPr/>
+          <p:nvPr/>
+        </p:nvSpPr>
+        <p:spPr>
+          <a:xfrm>
+            <a:off x="6172200" y="4069080"/>
+            <a:ext cx="5440680" cy="987552"/>
+          </a:xfrm>
+          <a:prstGeom prst="roundRect">
+            <a:avLst>
+              <a:gd name="adj" fmla="val 6000"/>
+            </a:avLst>
+          </a:prstGeom>
+          <a:solidFill>
+            <a:srgbClr val="F1F7F6"/>
+          </a:solidFill>
+          <a:ln>
+            <a:noFill/>
+          </a:ln>
+          <a:effectLst/>
+        </p:spPr>
+        <p:style>
+          <a:lnRef idx="1">
+            <a:schemeClr val="accent1"/>
+          </a:lnRef>
+          <a:fillRef idx="3">
+            <a:schemeClr val="accent1"/>
+          </a:fillRef>
+          <a:effectRef idx="2">
+            <a:schemeClr val="accent1"/>
+          </a:effectRef>
+          <a:fontRef idx="minor">
+            <a:schemeClr val="lt1"/>
+          </a:fontRef>
+        </p:style>
+        <p:txBody>
+          <a:bodyPr rtlCol="0" anchor="ctr"/>
+          <a:lstStyle/>
+          <a:p>
+            <a:pPr algn="ctr"/>
+          </a:p>
+        </p:txBody>
+      </p:sp>
+      <p:sp>
+        <p:nvSpPr>
+          <p:cNvPr id="20" name="TextBox 19"/>
+          <p:cNvSpPr txBox="1"/>
+          <p:nvPr/>
+        </p:nvSpPr>
+        <p:spPr>
+          <a:xfrm>
+            <a:off x="6446520" y="4197096"/>
+            <a:ext cx="4937760" cy="320040"/>
+          </a:xfrm>
+          <a:prstGeom prst="rect">
+            <a:avLst/>
+          </a:prstGeom>
+          <a:noFill/>
+        </p:spPr>
+        <p:txBody>
+          <a:bodyPr wrap="square" lIns="0" rIns="0" tIns="0" bIns="0" anchor="t">
+            <a:spAutoFit/>
+          </a:bodyPr>
+          <a:lstStyle/>
+          <a:p>
+            <a:pPr algn="l">
+              <a:spcAft>
+                <a:spcPts val="600"/>
+              </a:spcAft>
+            </a:pPr>
+            <a:r>
+              <a:rPr sz="1300" b="1">
+                <a:solidFill>
+                  <a:srgbClr val="0B5C5A"/>
+                </a:solidFill>
+                <a:latin typeface="맑은 고딕"/>
+                <a:ea typeface="맑은 고딕"/>
+              </a:rPr>
+              <a:t>출처 찾아 인용</a:t>
+            </a:r>
+          </a:p>
+        </p:txBody>
+      </p:sp>
+      <p:sp>
+        <p:nvSpPr>
+          <p:cNvPr id="21" name="TextBox 20"/>
+          <p:cNvSpPr txBox="1"/>
+          <p:nvPr/>
+        </p:nvSpPr>
+        <p:spPr>
+          <a:xfrm>
+            <a:off x="6446520" y="4544568"/>
+            <a:ext cx="4937760" cy="411480"/>
+          </a:xfrm>
+          <a:prstGeom prst="rect">
+            <a:avLst/>
+          </a:prstGeom>
+          <a:noFill/>
+        </p:spPr>
+        <p:txBody>
+          <a:bodyPr wrap="square" lIns="0" rIns="0" tIns="0" bIns="0" anchor="t">
+            <a:spAutoFit/>
+          </a:bodyPr>
+          <a:lstStyle/>
+          <a:p>
+            <a:pPr algn="l">
+              <a:spcAft>
+                <a:spcPts val="600"/>
+              </a:spcAft>
+            </a:pPr>
+            <a:r>
+              <a:rPr sz="1600" b="0">
+                <a:solidFill>
+                  <a:srgbClr val="1F292B"/>
+                </a:solidFill>
+                <a:latin typeface="맑은 고딕"/>
+                <a:ea typeface="맑은 고딕"/>
+              </a:rPr>
+              <a:t>“이 문장에 맞는 출처 찾아서 인용 달아줘”</a:t>
+            </a:r>
+          </a:p>
+        </p:txBody>
+      </p:sp>
+      <p:sp>
+        <p:nvSpPr>
+          <p:cNvPr id="22" name="Rounded Rectangle 21"/>
+          <p:cNvSpPr/>
+          <p:nvPr/>
+        </p:nvSpPr>
+        <p:spPr>
+          <a:xfrm>
+            <a:off x="548640" y="5212080"/>
+            <a:ext cx="5440680" cy="987552"/>
+          </a:xfrm>
+          <a:prstGeom prst="roundRect">
+            <a:avLst>
+              <a:gd name="adj" fmla="val 6000"/>
+            </a:avLst>
+          </a:prstGeom>
+          <a:solidFill>
+            <a:srgbClr val="F1F7F6"/>
+          </a:solidFill>
+          <a:ln>
+            <a:noFill/>
+          </a:ln>
+          <a:effectLst/>
+        </p:spPr>
+        <p:style>
+          <a:lnRef idx="1">
+            <a:schemeClr val="accent1"/>
+          </a:lnRef>
+          <a:fillRef idx="3">
+            <a:schemeClr val="accent1"/>
+          </a:fillRef>
+          <a:effectRef idx="2">
+            <a:schemeClr val="accent1"/>
+          </a:effectRef>
+          <a:fontRef idx="minor">
+            <a:schemeClr val="lt1"/>
+          </a:fontRef>
+        </p:style>
+        <p:txBody>
+          <a:bodyPr rtlCol="0" anchor="ctr"/>
+          <a:lstStyle/>
+          <a:p>
+            <a:pPr algn="ctr"/>
+          </a:p>
+        </p:txBody>
+      </p:sp>
+      <p:sp>
+        <p:nvSpPr>
+          <p:cNvPr id="23" name="TextBox 22"/>
+          <p:cNvSpPr txBox="1"/>
+          <p:nvPr/>
+        </p:nvSpPr>
+        <p:spPr>
+          <a:xfrm>
+            <a:off x="822959" y="5340096"/>
+            <a:ext cx="4937760" cy="320040"/>
+          </a:xfrm>
+          <a:prstGeom prst="rect">
+            <a:avLst/>
+          </a:prstGeom>
+          <a:noFill/>
+        </p:spPr>
+        <p:txBody>
+          <a:bodyPr wrap="square" lIns="0" rIns="0" tIns="0" bIns="0" anchor="t">
+            <a:spAutoFit/>
+          </a:bodyPr>
+          <a:lstStyle/>
+          <a:p>
+            <a:pPr algn="l">
+              <a:spcAft>
+                <a:spcPts val="600"/>
+              </a:spcAft>
+            </a:pPr>
+            <a:r>
+              <a:rPr sz="1300" b="1">
+                <a:solidFill>
+                  <a:srgbClr val="0B5C5A"/>
+                </a:solidFill>
+                <a:latin typeface="맑은 고딕"/>
+                <a:ea typeface="맑은 고딕"/>
+              </a:rPr>
+              <a:t>PDF 대기 목록</a:t>
+            </a:r>
+          </a:p>
+        </p:txBody>
+      </p:sp>
+      <p:sp>
+        <p:nvSpPr>
+          <p:cNvPr id="24" name="TextBox 23"/>
+          <p:cNvSpPr txBox="1"/>
+          <p:nvPr/>
+        </p:nvSpPr>
+        <p:spPr>
+          <a:xfrm>
+            <a:off x="822959" y="5687568"/>
+            <a:ext cx="4937760" cy="411480"/>
+          </a:xfrm>
+          <a:prstGeom prst="rect">
+            <a:avLst/>
+          </a:prstGeom>
+          <a:noFill/>
+        </p:spPr>
+        <p:txBody>
+          <a:bodyPr wrap="square" lIns="0" rIns="0" tIns="0" bIns="0" anchor="t">
+            <a:spAutoFit/>
+          </a:bodyPr>
+          <a:lstStyle/>
+          <a:p>
+            <a:pPr algn="l">
+              <a:spcAft>
+                <a:spcPts val="600"/>
+              </a:spcAft>
+            </a:pPr>
+            <a:r>
+              <a:rPr sz="1600" b="0">
+                <a:solidFill>
+                  <a:srgbClr val="1F292B"/>
+                </a:solidFill>
+                <a:latin typeface="맑은 고딕"/>
+                <a:ea typeface="맑은 고딕"/>
+              </a:rPr>
+              <a:t>“PDF 기다리는 논문 목록 보여줘”</a:t>
+            </a:r>
+          </a:p>
+        </p:txBody>
+      </p:sp>
+      <p:sp>
+        <p:nvSpPr>
+          <p:cNvPr id="25" name="Rounded Rectangle 24"/>
+          <p:cNvSpPr/>
+          <p:nvPr/>
+        </p:nvSpPr>
+        <p:spPr>
+          <a:xfrm>
+            <a:off x="6172200" y="5212080"/>
+            <a:ext cx="5440680" cy="987552"/>
+          </a:xfrm>
+          <a:prstGeom prst="roundRect">
+            <a:avLst>
+              <a:gd name="adj" fmla="val 6000"/>
+            </a:avLst>
+          </a:prstGeom>
+          <a:solidFill>
+            <a:srgbClr val="F1F7F6"/>
+          </a:solidFill>
+          <a:ln>
+            <a:noFill/>
+          </a:ln>
+          <a:effectLst/>
+        </p:spPr>
+        <p:style>
+          <a:lnRef idx="1">
+            <a:schemeClr val="accent1"/>
+          </a:lnRef>
+          <a:fillRef idx="3">
+            <a:schemeClr val="accent1"/>
+          </a:fillRef>
+          <a:effectRef idx="2">
+            <a:schemeClr val="accent1"/>
+          </a:effectRef>
+          <a:fontRef idx="minor">
+            <a:schemeClr val="lt1"/>
+          </a:fontRef>
+        </p:style>
+        <p:txBody>
+          <a:bodyPr rtlCol="0" anchor="ctr"/>
+          <a:lstStyle/>
+          <a:p>
+            <a:pPr algn="ctr"/>
+          </a:p>
+        </p:txBody>
+      </p:sp>
+      <p:sp>
+        <p:nvSpPr>
+          <p:cNvPr id="26" name="TextBox 25"/>
+          <p:cNvSpPr txBox="1"/>
+          <p:nvPr/>
+        </p:nvSpPr>
+        <p:spPr>
+          <a:xfrm>
+            <a:off x="6446520" y="5340096"/>
+            <a:ext cx="4937760" cy="320040"/>
+          </a:xfrm>
+          <a:prstGeom prst="rect">
+            <a:avLst/>
+          </a:prstGeom>
+          <a:noFill/>
+        </p:spPr>
+        <p:txBody>
+          <a:bodyPr wrap="square" lIns="0" rIns="0" tIns="0" bIns="0" anchor="t">
+            <a:spAutoFit/>
+          </a:bodyPr>
+          <a:lstStyle/>
+          <a:p>
+            <a:pPr algn="l">
+              <a:spcAft>
+                <a:spcPts val="600"/>
+              </a:spcAft>
+            </a:pPr>
+            <a:r>
+              <a:rPr sz="1300" b="1">
+                <a:solidFill>
+                  <a:srgbClr val="0B5C5A"/>
+                </a:solidFill>
+                <a:latin typeface="맑은 고딕"/>
+                <a:ea typeface="맑은 고딕"/>
+              </a:rPr>
+              <a:t>스킬 업데이트</a:t>
+            </a:r>
+          </a:p>
+        </p:txBody>
+      </p:sp>
+      <p:sp>
+        <p:nvSpPr>
+          <p:cNvPr id="27" name="TextBox 26"/>
+          <p:cNvSpPr txBox="1"/>
+          <p:nvPr/>
+        </p:nvSpPr>
+        <p:spPr>
+          <a:xfrm>
+            <a:off x="6446520" y="5687568"/>
+            <a:ext cx="4937760" cy="411480"/>
+          </a:xfrm>
+          <a:prstGeom prst="rect">
+            <a:avLst/>
+          </a:prstGeom>
+          <a:noFill/>
+        </p:spPr>
+        <p:txBody>
+          <a:bodyPr wrap="square" lIns="0" rIns="0" tIns="0" bIns="0" anchor="t">
+            <a:spAutoFit/>
+          </a:bodyPr>
+          <a:lstStyle/>
+          <a:p>
+            <a:pPr algn="l">
+              <a:spcAft>
+                <a:spcPts val="600"/>
+              </a:spcAft>
+            </a:pPr>
+            <a:r>
+              <a:rPr sz="1600" b="0">
+                <a:solidFill>
+                  <a:srgbClr val="1F292B"/>
+                </a:solidFill>
+                <a:latin typeface="맑은 고딕"/>
+                <a:ea typeface="맑은 고딕"/>
+              </a:rPr>
+              <a:t>“paper-summary 최신 버전으로 업데이트해줘”</a:t>
             </a:r>
           </a:p>
         </p:txBody>
@@ -11388,7 +11870,7 @@
     <p:bg>
       <p:bgPr>
         <a:solidFill>
-          <a:srgbClr val="0E2F2E"/>
+          <a:srgbClr val="FFFFFF"/>
         </a:solidFill>
         <a:effectLst/>
       </p:bgPr>
@@ -11402,14 +11884,14 @@
       <p:grpSpPr/>
       <p:sp>
         <p:nvSpPr>
-          <p:cNvPr id="2" name="TextBox 1"/>
+          <p:cNvPr id="2" name="Title"/>
           <p:cNvSpPr txBox="1"/>
           <p:nvPr/>
         </p:nvSpPr>
         <p:spPr>
           <a:xfrm>
-            <a:off x="822960" y="1828800"/>
-            <a:ext cx="10515600" cy="914400"/>
+            <a:off x="548640" y="411480"/>
+            <a:ext cx="11094415" cy="731520"/>
           </a:xfrm>
           <a:prstGeom prst="rect">
             <a:avLst/>
@@ -11428,14 +11910,14 @@
               </a:spcAft>
             </a:pPr>
             <a:r>
-              <a:rPr sz="4000" b="1">
-                <a:solidFill>
-                  <a:srgbClr val="FFFFFF"/>
-                </a:solidFill>
-                <a:latin typeface="맑은 고딕"/>
-                <a:ea typeface="맑은 고딕"/>
-              </a:rPr>
-              <a:t>지금 시작하기</a:t>
+              <a:rPr sz="3400" b="1">
+                <a:solidFill>
+                  <a:srgbClr val="0E2F2E"/>
+                </a:solidFill>
+                <a:latin typeface="맑은 고딕"/>
+                <a:ea typeface="맑은 고딕"/>
+              </a:rPr>
+              <a:t>라이브러리 구조와 자주 묻는 질문</a:t>
             </a:r>
           </a:p>
         </p:txBody>
@@ -11448,8 +11930,8 @@
         </p:nvSpPr>
         <p:spPr>
           <a:xfrm>
-            <a:off x="822960" y="2880360"/>
-            <a:ext cx="10515600" cy="548640"/>
+            <a:off x="548640" y="1143000"/>
+            <a:ext cx="11094415" cy="411480"/>
           </a:xfrm>
           <a:prstGeom prst="rect">
             <a:avLst/>
@@ -11468,14 +11950,14 @@
               </a:spcAft>
             </a:pPr>
             <a:r>
-              <a:rPr sz="1800" b="0">
-                <a:solidFill>
-                  <a:srgbClr val="C9DDDA"/>
-                </a:solidFill>
-                <a:latin typeface="맑은 고딕"/>
-                <a:ea typeface="맑은 고딕"/>
-              </a:rPr>
-              <a:t>Claude Code에서 이렇게 말해 보세요</a:t>
+              <a:rPr sz="1600" b="0">
+                <a:solidFill>
+                  <a:srgbClr val="5C6B6D"/>
+                </a:solidFill>
+                <a:latin typeface="맑은 고딕"/>
+                <a:ea typeface="맑은 고딕"/>
+              </a:rPr>
+              <a:t>기본 위치 ~/paper-library (환경 변수 PAPER_LIB로 변경)</a:t>
             </a:r>
           </a:p>
         </p:txBody>
@@ -11488,16 +11970,16 @@
         </p:nvSpPr>
         <p:spPr>
           <a:xfrm>
-            <a:off x="822960" y="3566160"/>
-            <a:ext cx="10515600" cy="914400"/>
+            <a:off x="548640" y="1783080"/>
+            <a:ext cx="5212080" cy="2651760"/>
           </a:xfrm>
           <a:prstGeom prst="roundRect">
             <a:avLst>
-              <a:gd name="adj" fmla="val 6000"/>
+              <a:gd name="adj" fmla="val 4000"/>
             </a:avLst>
           </a:prstGeom>
           <a:solidFill>
-            <a:srgbClr val="174543"/>
+            <a:srgbClr val="1B2628"/>
           </a:solidFill>
           <a:ln>
             <a:noFill/>
@@ -11534,8 +12016,8 @@
         </p:nvSpPr>
         <p:spPr>
           <a:xfrm>
-            <a:off x="1097280" y="3767328"/>
-            <a:ext cx="10058400" cy="548640"/>
+            <a:off x="777240" y="1947672"/>
+            <a:ext cx="4754880" cy="274320"/>
           </a:xfrm>
           <a:prstGeom prst="rect">
             <a:avLst/>
@@ -11554,14 +12036,14 @@
               </a:spcAft>
             </a:pPr>
             <a:r>
-              <a:rPr sz="2200" b="1">
-                <a:solidFill>
-                  <a:srgbClr val="FFFFFF"/>
-                </a:solidFill>
-                <a:latin typeface="맑은 고딕"/>
-                <a:ea typeface="맑은 고딕"/>
-              </a:rPr>
-              <a:t>/paper-summary  관심 주제를 정리해줘</a:t>
+              <a:rPr sz="1100" b="1">
+                <a:solidFill>
+                  <a:srgbClr val="8FD3C8"/>
+                </a:solidFill>
+                <a:latin typeface="맑은 고딕"/>
+                <a:ea typeface="맑은 고딕"/>
+              </a:rPr>
+              <a:t>폴더 구조</a:t>
             </a:r>
           </a:p>
         </p:txBody>
@@ -11574,8 +12056,8 @@
         </p:nvSpPr>
         <p:spPr>
           <a:xfrm>
-            <a:off x="822960" y="5212080"/>
-            <a:ext cx="10515600" cy="365760"/>
+            <a:off x="777240" y="2240279"/>
+            <a:ext cx="4754880" cy="2377440"/>
           </a:xfrm>
           <a:prstGeom prst="rect">
             <a:avLst/>
@@ -11590,18 +12072,624 @@
           <a:p>
             <a:pPr algn="l">
               <a:spcAft>
+                <a:spcPts val="200"/>
+              </a:spcAft>
+            </a:pPr>
+            <a:r>
+              <a:rPr sz="1300" b="0">
+                <a:solidFill>
+                  <a:srgbClr val="E6EDEE"/>
+                </a:solidFill>
+                <a:latin typeface="Consolas"/>
+                <a:ea typeface="맑은 고딕"/>
+              </a:rPr>
+              <a:t>paper-library/</a:t>
+            </a:r>
+          </a:p>
+          <a:p>
+            <a:pPr algn="l">
+              <a:spcAft>
+                <a:spcPts val="200"/>
+              </a:spcAft>
+            </a:pPr>
+            <a:r>
+              <a:rPr sz="1300" b="0">
+                <a:solidFill>
+                  <a:srgbClr val="E6EDEE"/>
+                </a:solidFill>
+                <a:latin typeface="Consolas"/>
+                <a:ea typeface="맑은 고딕"/>
+              </a:rPr>
+              <a:t>  index.html   library.json</a:t>
+            </a:r>
+          </a:p>
+          <a:p>
+            <a:pPr algn="l">
+              <a:spcAft>
+                <a:spcPts val="200"/>
+              </a:spcAft>
+            </a:pPr>
+            <a:r>
+              <a:rPr sz="1300" b="0">
+                <a:solidFill>
+                  <a:srgbClr val="E6EDEE"/>
+                </a:solidFill>
+                <a:latin typeface="Consolas"/>
+                <a:ea typeface="맑은 고딕"/>
+              </a:rPr>
+              <a:t>  library.bib</a:t>
+            </a:r>
+          </a:p>
+          <a:p>
+            <a:pPr algn="l">
+              <a:spcAft>
+                <a:spcPts val="200"/>
+              </a:spcAft>
+            </a:pPr>
+            <a:r>
+              <a:rPr sz="1300" b="0">
+                <a:solidFill>
+                  <a:srgbClr val="E6EDEE"/>
+                </a:solidFill>
+                <a:latin typeface="Consolas"/>
+                <a:ea typeface="맑은 고딕"/>
+              </a:rPr>
+              <a:t>  papers/Pstras2026estimating/</a:t>
+            </a:r>
+          </a:p>
+          <a:p>
+            <a:pPr algn="l">
+              <a:spcAft>
+                <a:spcPts val="200"/>
+              </a:spcAft>
+            </a:pPr>
+            <a:r>
+              <a:rPr sz="1300" b="0">
+                <a:solidFill>
+                  <a:srgbClr val="E6EDEE"/>
+                </a:solidFill>
+                <a:latin typeface="Consolas"/>
+                <a:ea typeface="맑은 고딕"/>
+              </a:rPr>
+              <a:t>    meta.json    paper.pdf</a:t>
+            </a:r>
+          </a:p>
+          <a:p>
+            <a:pPr algn="l">
+              <a:spcAft>
+                <a:spcPts val="200"/>
+              </a:spcAft>
+            </a:pPr>
+            <a:r>
+              <a:rPr sz="1300" b="0">
+                <a:solidFill>
+                  <a:srgbClr val="E6EDEE"/>
+                </a:solidFill>
+                <a:latin typeface="Consolas"/>
+                <a:ea typeface="맑은 고딕"/>
+              </a:rPr>
+              <a:t>    text.md      figures/</a:t>
+            </a:r>
+          </a:p>
+          <a:p>
+            <a:pPr algn="l">
+              <a:spcAft>
+                <a:spcPts val="200"/>
+              </a:spcAft>
+            </a:pPr>
+            <a:r>
+              <a:rPr sz="1300" b="0">
+                <a:solidFill>
+                  <a:srgbClr val="E6EDEE"/>
+                </a:solidFill>
+                <a:latin typeface="Consolas"/>
+                <a:ea typeface="맑은 고딕"/>
+              </a:rPr>
+              <a:t>    summary.md   index.html</a:t>
+            </a:r>
+          </a:p>
+        </p:txBody>
+      </p:sp>
+      <p:sp>
+        <p:nvSpPr>
+          <p:cNvPr id="7" name="Rounded Rectangle 6"/>
+          <p:cNvSpPr/>
+          <p:nvPr/>
+        </p:nvSpPr>
+        <p:spPr>
+          <a:xfrm>
+            <a:off x="6035040" y="1783080"/>
+            <a:ext cx="5623560" cy="987552"/>
+          </a:xfrm>
+          <a:prstGeom prst="roundRect">
+            <a:avLst>
+              <a:gd name="adj" fmla="val 6000"/>
+            </a:avLst>
+          </a:prstGeom>
+          <a:solidFill>
+            <a:srgbClr val="F1F7F6"/>
+          </a:solidFill>
+          <a:ln>
+            <a:noFill/>
+          </a:ln>
+          <a:effectLst/>
+        </p:spPr>
+        <p:style>
+          <a:lnRef idx="1">
+            <a:schemeClr val="accent1"/>
+          </a:lnRef>
+          <a:fillRef idx="3">
+            <a:schemeClr val="accent1"/>
+          </a:fillRef>
+          <a:effectRef idx="2">
+            <a:schemeClr val="accent1"/>
+          </a:effectRef>
+          <a:fontRef idx="minor">
+            <a:schemeClr val="lt1"/>
+          </a:fontRef>
+        </p:style>
+        <p:txBody>
+          <a:bodyPr rtlCol="0" anchor="ctr"/>
+          <a:lstStyle/>
+          <a:p>
+            <a:pPr algn="ctr"/>
+          </a:p>
+        </p:txBody>
+      </p:sp>
+      <p:sp>
+        <p:nvSpPr>
+          <p:cNvPr id="8" name="TextBox 7"/>
+          <p:cNvSpPr txBox="1"/>
+          <p:nvPr/>
+        </p:nvSpPr>
+        <p:spPr>
+          <a:xfrm>
+            <a:off x="6263640" y="1901952"/>
+            <a:ext cx="5212080" cy="365760"/>
+          </a:xfrm>
+          <a:prstGeom prst="rect">
+            <a:avLst/>
+          </a:prstGeom>
+          <a:noFill/>
+        </p:spPr>
+        <p:txBody>
+          <a:bodyPr wrap="square" lIns="0" rIns="0" tIns="0" bIns="0" anchor="t">
+            <a:spAutoFit/>
+          </a:bodyPr>
+          <a:lstStyle/>
+          <a:p>
+            <a:pPr algn="l">
+              <a:spcAft>
                 <a:spcPts val="600"/>
               </a:spcAft>
             </a:pPr>
             <a:r>
-              <a:rPr sz="1400" b="0">
-                <a:solidFill>
-                  <a:srgbClr val="8FD3C8"/>
-                </a:solidFill>
-                <a:latin typeface="Consolas"/>
-                <a:ea typeface="맑은 고딕"/>
-              </a:rPr>
-              <a:t>github.com/emilyJ7/paper-summary  ·  MIT License</a:t>
+              <a:rPr sz="1500" b="1">
+                <a:solidFill>
+                  <a:srgbClr val="0E2F2E"/>
+                </a:solidFill>
+                <a:latin typeface="맑은 고딕"/>
+                <a:ea typeface="맑은 고딕"/>
+              </a:rPr>
+              <a:t>Q. API 비용이 드나요?</a:t>
+            </a:r>
+          </a:p>
+        </p:txBody>
+      </p:sp>
+      <p:sp>
+        <p:nvSpPr>
+          <p:cNvPr id="9" name="TextBox 8"/>
+          <p:cNvSpPr txBox="1"/>
+          <p:nvPr/>
+        </p:nvSpPr>
+        <p:spPr>
+          <a:xfrm>
+            <a:off x="6263640" y="2267712"/>
+            <a:ext cx="5212080" cy="457200"/>
+          </a:xfrm>
+          <a:prstGeom prst="rect">
+            <a:avLst/>
+          </a:prstGeom>
+          <a:noFill/>
+        </p:spPr>
+        <p:txBody>
+          <a:bodyPr wrap="square" lIns="0" rIns="0" tIns="0" bIns="0" anchor="t">
+            <a:spAutoFit/>
+          </a:bodyPr>
+          <a:lstStyle/>
+          <a:p>
+            <a:pPr algn="l">
+              <a:spcAft>
+                <a:spcPts val="600"/>
+              </a:spcAft>
+            </a:pPr>
+            <a:r>
+              <a:rPr sz="1300" b="0">
+                <a:solidFill>
+                  <a:srgbClr val="1F292B"/>
+                </a:solidFill>
+                <a:latin typeface="맑은 고딕"/>
+                <a:ea typeface="맑은 고딕"/>
+              </a:rPr>
+              <a:t>아니요. 무료 공개 API만 쓰고 요약은 대화 안에서 합니다.</a:t>
+            </a:r>
+          </a:p>
+        </p:txBody>
+      </p:sp>
+      <p:sp>
+        <p:nvSpPr>
+          <p:cNvPr id="10" name="Rounded Rectangle 9"/>
+          <p:cNvSpPr/>
+          <p:nvPr/>
+        </p:nvSpPr>
+        <p:spPr>
+          <a:xfrm>
+            <a:off x="6035040" y="2898648"/>
+            <a:ext cx="5623560" cy="987552"/>
+          </a:xfrm>
+          <a:prstGeom prst="roundRect">
+            <a:avLst>
+              <a:gd name="adj" fmla="val 6000"/>
+            </a:avLst>
+          </a:prstGeom>
+          <a:solidFill>
+            <a:srgbClr val="F1F7F6"/>
+          </a:solidFill>
+          <a:ln>
+            <a:noFill/>
+          </a:ln>
+          <a:effectLst/>
+        </p:spPr>
+        <p:style>
+          <a:lnRef idx="1">
+            <a:schemeClr val="accent1"/>
+          </a:lnRef>
+          <a:fillRef idx="3">
+            <a:schemeClr val="accent1"/>
+          </a:fillRef>
+          <a:effectRef idx="2">
+            <a:schemeClr val="accent1"/>
+          </a:effectRef>
+          <a:fontRef idx="minor">
+            <a:schemeClr val="lt1"/>
+          </a:fontRef>
+        </p:style>
+        <p:txBody>
+          <a:bodyPr rtlCol="0" anchor="ctr"/>
+          <a:lstStyle/>
+          <a:p>
+            <a:pPr algn="ctr"/>
+          </a:p>
+        </p:txBody>
+      </p:sp>
+      <p:sp>
+        <p:nvSpPr>
+          <p:cNvPr id="11" name="TextBox 10"/>
+          <p:cNvSpPr txBox="1"/>
+          <p:nvPr/>
+        </p:nvSpPr>
+        <p:spPr>
+          <a:xfrm>
+            <a:off x="6263640" y="3017520"/>
+            <a:ext cx="5212080" cy="365760"/>
+          </a:xfrm>
+          <a:prstGeom prst="rect">
+            <a:avLst/>
+          </a:prstGeom>
+          <a:noFill/>
+        </p:spPr>
+        <p:txBody>
+          <a:bodyPr wrap="square" lIns="0" rIns="0" tIns="0" bIns="0" anchor="t">
+            <a:spAutoFit/>
+          </a:bodyPr>
+          <a:lstStyle/>
+          <a:p>
+            <a:pPr algn="l">
+              <a:spcAft>
+                <a:spcPts val="600"/>
+              </a:spcAft>
+            </a:pPr>
+            <a:r>
+              <a:rPr sz="1500" b="1">
+                <a:solidFill>
+                  <a:srgbClr val="0E2F2E"/>
+                </a:solidFill>
+                <a:latin typeface="맑은 고딕"/>
+                <a:ea typeface="맑은 고딕"/>
+              </a:rPr>
+              <a:t>Q. 그림이 잘못 잘렸어요</a:t>
+            </a:r>
+          </a:p>
+        </p:txBody>
+      </p:sp>
+      <p:sp>
+        <p:nvSpPr>
+          <p:cNvPr id="12" name="TextBox 11"/>
+          <p:cNvSpPr txBox="1"/>
+          <p:nvPr/>
+        </p:nvSpPr>
+        <p:spPr>
+          <a:xfrm>
+            <a:off x="6263640" y="3383280"/>
+            <a:ext cx="5212080" cy="457200"/>
+          </a:xfrm>
+          <a:prstGeom prst="rect">
+            <a:avLst/>
+          </a:prstGeom>
+          <a:noFill/>
+        </p:spPr>
+        <p:txBody>
+          <a:bodyPr wrap="square" lIns="0" rIns="0" tIns="0" bIns="0" anchor="t">
+            <a:spAutoFit/>
+          </a:bodyPr>
+          <a:lstStyle/>
+          <a:p>
+            <a:pPr algn="l">
+              <a:spcAft>
+                <a:spcPts val="600"/>
+              </a:spcAft>
+            </a:pPr>
+            <a:r>
+              <a:rPr sz="1300" b="0">
+                <a:solidFill>
+                  <a:srgbClr val="1F292B"/>
+                </a:solidFill>
+                <a:latin typeface="맑은 고딕"/>
+                <a:ea typeface="맑은 고딕"/>
+              </a:rPr>
+              <a:t>캡션 기준이라 특이한 PDF는 놓칠 수 있고, 요약 때 걸러냄</a:t>
+            </a:r>
+          </a:p>
+        </p:txBody>
+      </p:sp>
+      <p:sp>
+        <p:nvSpPr>
+          <p:cNvPr id="13" name="Rounded Rectangle 12"/>
+          <p:cNvSpPr/>
+          <p:nvPr/>
+        </p:nvSpPr>
+        <p:spPr>
+          <a:xfrm>
+            <a:off x="6035040" y="4014215"/>
+            <a:ext cx="5623560" cy="987552"/>
+          </a:xfrm>
+          <a:prstGeom prst="roundRect">
+            <a:avLst>
+              <a:gd name="adj" fmla="val 6000"/>
+            </a:avLst>
+          </a:prstGeom>
+          <a:solidFill>
+            <a:srgbClr val="F1F7F6"/>
+          </a:solidFill>
+          <a:ln>
+            <a:noFill/>
+          </a:ln>
+          <a:effectLst/>
+        </p:spPr>
+        <p:style>
+          <a:lnRef idx="1">
+            <a:schemeClr val="accent1"/>
+          </a:lnRef>
+          <a:fillRef idx="3">
+            <a:schemeClr val="accent1"/>
+          </a:fillRef>
+          <a:effectRef idx="2">
+            <a:schemeClr val="accent1"/>
+          </a:effectRef>
+          <a:fontRef idx="minor">
+            <a:schemeClr val="lt1"/>
+          </a:fontRef>
+        </p:style>
+        <p:txBody>
+          <a:bodyPr rtlCol="0" anchor="ctr"/>
+          <a:lstStyle/>
+          <a:p>
+            <a:pPr algn="ctr"/>
+          </a:p>
+        </p:txBody>
+      </p:sp>
+      <p:sp>
+        <p:nvSpPr>
+          <p:cNvPr id="14" name="TextBox 13"/>
+          <p:cNvSpPr txBox="1"/>
+          <p:nvPr/>
+        </p:nvSpPr>
+        <p:spPr>
+          <a:xfrm>
+            <a:off x="6263640" y="4133087"/>
+            <a:ext cx="5212080" cy="365760"/>
+          </a:xfrm>
+          <a:prstGeom prst="rect">
+            <a:avLst/>
+          </a:prstGeom>
+          <a:noFill/>
+        </p:spPr>
+        <p:txBody>
+          <a:bodyPr wrap="square" lIns="0" rIns="0" tIns="0" bIns="0" anchor="t">
+            <a:spAutoFit/>
+          </a:bodyPr>
+          <a:lstStyle/>
+          <a:p>
+            <a:pPr algn="l">
+              <a:spcAft>
+                <a:spcPts val="600"/>
+              </a:spcAft>
+            </a:pPr>
+            <a:r>
+              <a:rPr sz="1500" b="1">
+                <a:solidFill>
+                  <a:srgbClr val="0E2F2E"/>
+                </a:solidFill>
+                <a:latin typeface="맑은 고딕"/>
+                <a:ea typeface="맑은 고딕"/>
+              </a:rPr>
+              <a:t>Q. 다른 PC로 옮기려면?</a:t>
+            </a:r>
+          </a:p>
+        </p:txBody>
+      </p:sp>
+      <p:sp>
+        <p:nvSpPr>
+          <p:cNvPr id="15" name="TextBox 14"/>
+          <p:cNvSpPr txBox="1"/>
+          <p:nvPr/>
+        </p:nvSpPr>
+        <p:spPr>
+          <a:xfrm>
+            <a:off x="6263640" y="4498848"/>
+            <a:ext cx="5212080" cy="457200"/>
+          </a:xfrm>
+          <a:prstGeom prst="rect">
+            <a:avLst/>
+          </a:prstGeom>
+          <a:noFill/>
+        </p:spPr>
+        <p:txBody>
+          <a:bodyPr wrap="square" lIns="0" rIns="0" tIns="0" bIns="0" anchor="t">
+            <a:spAutoFit/>
+          </a:bodyPr>
+          <a:lstStyle/>
+          <a:p>
+            <a:pPr algn="l">
+              <a:spcAft>
+                <a:spcPts val="600"/>
+              </a:spcAft>
+            </a:pPr>
+            <a:r>
+              <a:rPr sz="1300" b="0">
+                <a:solidFill>
+                  <a:srgbClr val="1F292B"/>
+                </a:solidFill>
+                <a:latin typeface="맑은 고딕"/>
+                <a:ea typeface="맑은 고딕"/>
+              </a:rPr>
+              <a:t>paper-library 폴더를 통째로 복사. 공개 저장소엔 올리지 마세요.</a:t>
+            </a:r>
+          </a:p>
+        </p:txBody>
+      </p:sp>
+      <p:sp>
+        <p:nvSpPr>
+          <p:cNvPr id="16" name="Rounded Rectangle 15"/>
+          <p:cNvSpPr/>
+          <p:nvPr/>
+        </p:nvSpPr>
+        <p:spPr>
+          <a:xfrm>
+            <a:off x="6035040" y="5129784"/>
+            <a:ext cx="5623560" cy="987552"/>
+          </a:xfrm>
+          <a:prstGeom prst="roundRect">
+            <a:avLst>
+              <a:gd name="adj" fmla="val 6000"/>
+            </a:avLst>
+          </a:prstGeom>
+          <a:solidFill>
+            <a:srgbClr val="F1F7F6"/>
+          </a:solidFill>
+          <a:ln>
+            <a:noFill/>
+          </a:ln>
+          <a:effectLst/>
+        </p:spPr>
+        <p:style>
+          <a:lnRef idx="1">
+            <a:schemeClr val="accent1"/>
+          </a:lnRef>
+          <a:fillRef idx="3">
+            <a:schemeClr val="accent1"/>
+          </a:fillRef>
+          <a:effectRef idx="2">
+            <a:schemeClr val="accent1"/>
+          </a:effectRef>
+          <a:fontRef idx="minor">
+            <a:schemeClr val="lt1"/>
+          </a:fontRef>
+        </p:style>
+        <p:txBody>
+          <a:bodyPr rtlCol="0" anchor="ctr"/>
+          <a:lstStyle/>
+          <a:p>
+            <a:pPr algn="ctr"/>
+          </a:p>
+        </p:txBody>
+      </p:sp>
+      <p:sp>
+        <p:nvSpPr>
+          <p:cNvPr id="17" name="TextBox 16"/>
+          <p:cNvSpPr txBox="1"/>
+          <p:nvPr/>
+        </p:nvSpPr>
+        <p:spPr>
+          <a:xfrm>
+            <a:off x="6263640" y="5248656"/>
+            <a:ext cx="5212080" cy="365760"/>
+          </a:xfrm>
+          <a:prstGeom prst="rect">
+            <a:avLst/>
+          </a:prstGeom>
+          <a:noFill/>
+        </p:spPr>
+        <p:txBody>
+          <a:bodyPr wrap="square" lIns="0" rIns="0" tIns="0" bIns="0" anchor="t">
+            <a:spAutoFit/>
+          </a:bodyPr>
+          <a:lstStyle/>
+          <a:p>
+            <a:pPr algn="l">
+              <a:spcAft>
+                <a:spcPts val="600"/>
+              </a:spcAft>
+            </a:pPr>
+            <a:r>
+              <a:rPr sz="1500" b="1">
+                <a:solidFill>
+                  <a:srgbClr val="0E2F2E"/>
+                </a:solidFill>
+                <a:latin typeface="맑은 고딕"/>
+                <a:ea typeface="맑은 고딕"/>
+              </a:rPr>
+              <a:t>Q. 최신 버전 받기</a:t>
+            </a:r>
+          </a:p>
+        </p:txBody>
+      </p:sp>
+      <p:sp>
+        <p:nvSpPr>
+          <p:cNvPr id="18" name="TextBox 17"/>
+          <p:cNvSpPr txBox="1"/>
+          <p:nvPr/>
+        </p:nvSpPr>
+        <p:spPr>
+          <a:xfrm>
+            <a:off x="6263640" y="5614416"/>
+            <a:ext cx="5212080" cy="457200"/>
+          </a:xfrm>
+          <a:prstGeom prst="rect">
+            <a:avLst/>
+          </a:prstGeom>
+          <a:noFill/>
+        </p:spPr>
+        <p:txBody>
+          <a:bodyPr wrap="square" lIns="0" rIns="0" tIns="0" bIns="0" anchor="t">
+            <a:spAutoFit/>
+          </a:bodyPr>
+          <a:lstStyle/>
+          <a:p>
+            <a:pPr algn="l">
+              <a:spcAft>
+                <a:spcPts val="600"/>
+              </a:spcAft>
+            </a:pPr>
+            <a:r>
+              <a:rPr sz="1300" b="0">
+                <a:solidFill>
+                  <a:srgbClr val="1F292B"/>
+                </a:solidFill>
+                <a:latin typeface="맑은 고딕"/>
+                <a:ea typeface="맑은 고딕"/>
+              </a:rPr>
+              <a:t>“paper-summary 스킬 최신 버전으로 업데이트해줘”</a:t>
             </a:r>
           </a:p>
         </p:txBody>

</xml_diff>

<commit_message>
Make IEEE numbered citations the default
- cite defaults to IEEE: [1] in the text, references numbered in
  order of first appearance; APA only when asked
- SKILL.md, README and usage guide (4 formats) use "참고문헌 달아줘"
  for the default and show APA as the alternative

Co-Authored-By: Claude Opus 5.5 <noreply@anthropic.com>
</commit_message>
<xml_diff>
--- a/docs/paper-summary_사용가이드.pptx
+++ b/docs/paper-summary_사용가이드.pptx
@@ -5735,7 +5735,7 @@
                 <a:ea typeface="맑은 고딕"/>
               </a:rPr>
               <a:t>HRV 논문들로 서론 쓰고
-참고문헌 APA로 달아줘</a:t>
+참고문헌 달아줘</a:t>
             </a:r>
           </a:p>
         </p:txBody>
@@ -8946,7 +8946,7 @@
                 <a:latin typeface="맑은 고딕"/>
                 <a:ea typeface="맑은 고딕"/>
               </a:rPr>
-              <a:t>“라이브러리 HRV 논문들로 연구 배경 써주고 참고문헌 APA로 달아줘”</a:t>
+              <a:t>“라이브러리 HRV 논문들로 연구 배경 써주고 참고문헌 달아줘”</a:t>
             </a:r>
           </a:p>
         </p:txBody>
@@ -9211,7 +9211,7 @@
             </a:avLst>
           </a:prstGeom>
           <a:solidFill>
-            <a:srgbClr val="F1F7F6"/>
+            <a:srgbClr val="D8EEEA"/>
           </a:solidFill>
           <a:ln>
             <a:noFill/>
@@ -9275,7 +9275,7 @@
                 <a:latin typeface="맑은 고딕"/>
                 <a:ea typeface="맑은 고딕"/>
               </a:rPr>
-              <a:t>APA  </a:t>
+              <a:t>기본 (IEEE)  </a:t>
             </a:r>
             <a:r>
               <a:rPr sz="1500" b="0">
@@ -9285,7 +9285,7 @@
                 <a:latin typeface="맑은 고딕"/>
                 <a:ea typeface="맑은 고딕"/>
               </a:rPr>
-              <a:t>… 보고됨 (Pstras et al., 2026, p. 7).</a:t>
+              <a:t>… 보고됨 [1, p. 7].</a:t>
             </a:r>
           </a:p>
         </p:txBody>
@@ -9371,7 +9371,7 @@
                 <a:latin typeface="맑은 고딕"/>
                 <a:ea typeface="맑은 고딕"/>
               </a:rPr>
-              <a:t>IEEE  </a:t>
+              <a:t>“APA로”  </a:t>
             </a:r>
             <a:r>
               <a:rPr sz="1500" b="0">
@@ -9381,7 +9381,7 @@
                 <a:latin typeface="맑은 고딕"/>
                 <a:ea typeface="맑은 고딕"/>
               </a:rPr>
-              <a:t>… 보고됨 [1, p. 7].</a:t>
+              <a:t>… 보고됨 (Pstras et al., 2026, p. 7).</a:t>
             </a:r>
           </a:p>
         </p:txBody>
@@ -9406,8 +9406,8 @@
               </a:tblPr>
               <a:tblGrid>
                 <a:gridCol w="3017520"/>
-                <a:gridCol w="5120640"/>
-                <a:gridCol w="2971800"/>
+                <a:gridCol w="3291840"/>
+                <a:gridCol w="4800600"/>
               </a:tblGrid>
               <a:tr h="388620">
                 <a:tc>
@@ -9444,7 +9444,7 @@
                           </a:solidFill>
                           <a:latin typeface="맑은 고딕"/>
                         </a:rPr>
-                        <a:t>APA</a:t>
+                        <a:t>기본 (IEEE 번호식)</a:t>
                       </a:r>
                     </a:p>
                   </a:txBody>
@@ -9466,7 +9466,7 @@
                           </a:solidFill>
                           <a:latin typeface="맑은 고딕"/>
                         </a:rPr>
-                        <a:t>IEEE</a:t>
+                        <a:t>APA로 요청하면</a:t>
                       </a:r>
                     </a:p>
                   </a:txBody>
@@ -9512,7 +9512,7 @@
                           </a:solidFill>
                           <a:latin typeface="맑은 고딕"/>
                         </a:rPr>
-                        <a:t>(Pstras et al., 2026)</a:t>
+                        <a:t>[1]</a:t>
                       </a:r>
                     </a:p>
                   </a:txBody>
@@ -9534,7 +9534,7 @@
                           </a:solidFill>
                           <a:latin typeface="맑은 고딕"/>
                         </a:rPr>
-                        <a:t>[1]</a:t>
+                        <a:t>(Pstras et al., 2026)</a:t>
                       </a:r>
                     </a:p>
                   </a:txBody>
@@ -9580,7 +9580,7 @@
                           </a:solidFill>
                           <a:latin typeface="맑은 고딕"/>
                         </a:rPr>
-                        <a:t>(…, 2026, p. 7)</a:t>
+                        <a:t>[1, p. 7]</a:t>
                       </a:r>
                     </a:p>
                   </a:txBody>
@@ -9602,7 +9602,7 @@
                           </a:solidFill>
                           <a:latin typeface="맑은 고딕"/>
                         </a:rPr>
-                        <a:t>[1, p. 7]</a:t>
+                        <a:t>(…, 2026, p. 7)</a:t>
                       </a:r>
                     </a:p>
                   </a:txBody>
@@ -9648,7 +9648,7 @@
                           </a:solidFill>
                           <a:latin typeface="맑은 고딕"/>
                         </a:rPr>
-                        <a:t>(Pstras et al., 2026; Rouast, 2025)</a:t>
+                        <a:t>[1, 2]</a:t>
                       </a:r>
                     </a:p>
                   </a:txBody>
@@ -9670,7 +9670,7 @@
                           </a:solidFill>
                           <a:latin typeface="맑은 고딕"/>
                         </a:rPr>
-                        <a:t>[1, 2]</a:t>
+                        <a:t>(Pstras et al., 2026; Rouast, 2025)</a:t>
                       </a:r>
                     </a:p>
                   </a:txBody>
@@ -9720,7 +9720,7 @@
                 <a:latin typeface="맑은 고딕"/>
                 <a:ea typeface="맑은 고딕"/>
               </a:rPr>
-              <a:t>“draft.md 참고문헌 IEEE로 달아줘” · “한글 문서용 표로” · 키를 모르면 “SDNN 다룬 논문 인용 키 알려줘”</a:t>
+              <a:t>“draft.md 참고문헌 달아줘” → 본문 [1] + 번호순 참고문헌 · “한글 문서용 표로” · “APA로”</a:t>
             </a:r>
           </a:p>
         </p:txBody>

</xml_diff>